<commit_message>
Verify pilot workflows and refresh demo presentation
</commit_message>
<xml_diff>
--- a/docs/CVRDE_Demo_Presentation.pptx
+++ b/docs/CVRDE_Demo_Presentation.pptx
@@ -1480,7 +1480,7 @@
     <p:bg>
       <p:bgPr>
         <a:solidFill>
-          <a:srgbClr val="F6F9F9"/>
+          <a:srgbClr val="FAFAFA"/>
         </a:solidFill>
       </p:bgPr>
     </p:bg>
@@ -1507,17 +1507,17 @@
         <p:spPr>
           <a:xfrm>
             <a:off x="0" y="0"/>
-            <a:ext cx="12191695" cy="146304"/>
-          </a:xfrm>
-          <a:prstGeom prst="rect">
-            <a:avLst/>
-          </a:prstGeom>
-          <a:solidFill>
-            <a:srgbClr val="087E73"/>
+            <a:ext cx="109728" cy="6858000"/>
+          </a:xfrm>
+          <a:prstGeom prst="rect">
+            <a:avLst/>
+          </a:prstGeom>
+          <a:solidFill>
+            <a:srgbClr val="4338CA"/>
           </a:solidFill>
           <a:ln w="12700">
             <a:solidFill>
-              <a:srgbClr val="087E73"/>
+              <a:srgbClr val="4338CA"/>
             </a:solidFill>
             <a:prstDash val="solid"/>
           </a:ln>
@@ -1531,8 +1531,8 @@
         </p:nvSpPr>
         <p:spPr>
           <a:xfrm>
-            <a:off x="438912" y="310896"/>
-            <a:ext cx="11064240" cy="384048"/>
+            <a:off x="411480" y="274320"/>
+            <a:ext cx="9144000" cy="182880"/>
           </a:xfrm>
           <a:prstGeom prst="rect">
             <a:avLst/>
@@ -1548,53 +1548,53 @@
               <a:buNone/>
             </a:pPr>
             <a:r>
-              <a:rPr lang="en-US" sz="2500" b="1" dirty="0">
-                <a:solidFill>
-                  <a:srgbClr val="14353E"/>
+              <a:rPr lang="en-US" sz="800" b="1" spc="180" kern="0" dirty="0">
+                <a:solidFill>
+                  <a:srgbClr val="4338CA"/>
+                </a:solidFill>
+              </a:rPr>
+              <a:t>PILOT DEMONSTRATION</a:t>
+            </a:r>
+            <a:endParaRPr lang="en-US" sz="800" dirty="0"/>
+          </a:p>
+        </p:txBody>
+      </p:sp>
+      <p:sp>
+        <p:nvSpPr>
+          <p:cNvPr id="4" name="Text 2"/>
+          <p:cNvSpPr/>
+          <p:nvPr/>
+        </p:nvSpPr>
+        <p:spPr>
+          <a:xfrm>
+            <a:off x="411480" y="530352"/>
+            <a:ext cx="11064240" cy="457200"/>
+          </a:xfrm>
+          <a:prstGeom prst="rect">
+            <a:avLst/>
+          </a:prstGeom>
+          <a:noFill/>
+          <a:ln/>
+        </p:spPr>
+        <p:txBody>
+          <a:bodyPr wrap="square" lIns="0" tIns="0" rIns="0" bIns="0" rtlCol="0" anchor="ctr"/>
+          <a:lstStyle/>
+          <a:p>
+            <a:pPr indent="0" marL="0">
+              <a:buNone/>
+            </a:pPr>
+            <a:r>
+              <a:rPr lang="en-US" sz="2800" b="1" dirty="0">
+                <a:solidFill>
+                  <a:srgbClr val="0A0A0A"/>
                 </a:solidFill>
                 <a:latin typeface="Aptos Display" pitchFamily="34" charset="0"/>
                 <a:ea typeface="Aptos Display" pitchFamily="34" charset="-122"/>
                 <a:cs typeface="Aptos Display" pitchFamily="34" charset="-120"/>
               </a:rPr>
-              <a:t>CVRDE Work Management Demo</a:t>
-            </a:r>
-            <a:endParaRPr lang="en-US" sz="2500" dirty="0"/>
-          </a:p>
-        </p:txBody>
-      </p:sp>
-      <p:sp>
-        <p:nvSpPr>
-          <p:cNvPr id="4" name="Text 2"/>
-          <p:cNvSpPr/>
-          <p:nvPr/>
-        </p:nvSpPr>
-        <p:spPr>
-          <a:xfrm>
-            <a:off x="457200" y="758952"/>
-            <a:ext cx="10972800" cy="292608"/>
-          </a:xfrm>
-          <a:prstGeom prst="rect">
-            <a:avLst/>
-          </a:prstGeom>
-          <a:noFill/>
-          <a:ln/>
-        </p:spPr>
-        <p:txBody>
-          <a:bodyPr wrap="square" lIns="0" tIns="0" rIns="0" bIns="0" rtlCol="0" anchor="ctr"/>
-          <a:lstStyle/>
-          <a:p>
-            <a:pPr indent="0" marL="0">
-              <a:buNone/>
-            </a:pPr>
-            <a:r>
-              <a:rPr lang="en-US" sz="1050" dirty="0">
-                <a:solidFill>
-                  <a:srgbClr val="607984"/>
-                </a:solidFill>
-              </a:rPr>
-              <a:t>Pilot workflow beneath the Project Manager level</a:t>
-            </a:r>
-            <a:endParaRPr lang="en-US" sz="1050" dirty="0"/>
+              <a:t>CVRDE Work Management</a:t>
+            </a:r>
+            <a:endParaRPr lang="en-US" sz="2800" dirty="0"/>
           </a:p>
         </p:txBody>
       </p:sp>
@@ -1606,20 +1606,18 @@
         </p:nvSpPr>
         <p:spPr>
           <a:xfrm>
-            <a:off x="365760" y="1243584"/>
-            <a:ext cx="7818120" cy="5010912"/>
-          </a:xfrm>
-          <a:prstGeom prst="roundRect">
-            <a:avLst>
-              <a:gd name="adj" fmla="val 1825"/>
-            </a:avLst>
+            <a:off x="365760" y="1207008"/>
+            <a:ext cx="7818120" cy="5029200"/>
+          </a:xfrm>
+          <a:prstGeom prst="rect">
+            <a:avLst/>
           </a:prstGeom>
           <a:solidFill>
             <a:srgbClr val="FFFFFF"/>
           </a:solidFill>
           <a:ln w="12700">
             <a:solidFill>
-              <a:srgbClr val="DCE8E8"/>
+              <a:srgbClr val="E4E4E7"/>
             </a:solidFill>
             <a:prstDash val="solid"/>
           </a:ln>
@@ -1641,8 +1639,8 @@
         </p:blipFill>
         <p:spPr>
           <a:xfrm>
-            <a:off x="411480" y="1289304"/>
-            <a:ext cx="7726680" cy="4919472"/>
+            <a:off x="402336" y="1243584"/>
+            <a:ext cx="7744968" cy="4956048"/>
           </a:xfrm>
           <a:prstGeom prst="rect">
             <a:avLst/>
@@ -1657,20 +1655,18 @@
         </p:nvSpPr>
         <p:spPr>
           <a:xfrm>
-            <a:off x="8439912" y="1243584"/>
-            <a:ext cx="3364992" cy="5010912"/>
-          </a:xfrm>
-          <a:prstGeom prst="roundRect">
-            <a:avLst>
-              <a:gd name="adj" fmla="val 2717"/>
-            </a:avLst>
+            <a:off x="8439912" y="1207008"/>
+            <a:ext cx="3364992" cy="5029200"/>
+          </a:xfrm>
+          <a:prstGeom prst="rect">
+            <a:avLst/>
           </a:prstGeom>
           <a:solidFill>
             <a:srgbClr val="FFFFFF"/>
           </a:solidFill>
           <a:ln w="12700">
             <a:solidFill>
-              <a:srgbClr val="DCE8E8"/>
+              <a:srgbClr val="E4E4E7"/>
             </a:solidFill>
             <a:prstDash val="solid"/>
           </a:ln>
@@ -1684,8 +1680,8 @@
         </p:nvSpPr>
         <p:spPr>
           <a:xfrm>
-            <a:off x="8686800" y="1536192"/>
-            <a:ext cx="2834640" cy="320040"/>
+            <a:off x="8686800" y="1545336"/>
+            <a:ext cx="2834640" cy="210312"/>
           </a:xfrm>
           <a:prstGeom prst="rect">
             <a:avLst/>
@@ -1701,14 +1697,14 @@
               <a:buNone/>
             </a:pPr>
             <a:r>
-              <a:rPr lang="en-US" sz="1500" b="1" dirty="0">
-                <a:solidFill>
-                  <a:srgbClr val="14353E"/>
-                </a:solidFill>
-              </a:rPr>
-              <a:t>What this shows</a:t>
-            </a:r>
-            <a:endParaRPr lang="en-US" sz="1500" dirty="0"/>
+              <a:rPr lang="en-US" sz="900" b="1" spc="160" kern="0" dirty="0">
+                <a:solidFill>
+                  <a:srgbClr val="4338CA"/>
+                </a:solidFill>
+              </a:rPr>
+              <a:t>IN THIS VIEW</a:t>
+            </a:r>
+            <a:endParaRPr lang="en-US" sz="900" dirty="0"/>
           </a:p>
         </p:txBody>
       </p:sp>
@@ -1720,18 +1716,18 @@
         </p:nvSpPr>
         <p:spPr>
           <a:xfrm>
-            <a:off x="8695944" y="2112264"/>
-            <a:ext cx="91440" cy="91440"/>
-          </a:xfrm>
-          <a:prstGeom prst="ellipse">
-            <a:avLst/>
-          </a:prstGeom>
-          <a:solidFill>
-            <a:srgbClr val="087E73"/>
+            <a:off x="8695944" y="2066544"/>
+            <a:ext cx="73152" cy="73152"/>
+          </a:xfrm>
+          <a:prstGeom prst="rect">
+            <a:avLst/>
+          </a:prstGeom>
+          <a:solidFill>
+            <a:srgbClr val="4338CA"/>
           </a:solidFill>
           <a:ln w="12700">
             <a:solidFill>
-              <a:srgbClr val="087E73"/>
+              <a:srgbClr val="4338CA"/>
             </a:solidFill>
             <a:prstDash val="solid"/>
           </a:ln>
@@ -1745,8 +1741,8 @@
         </p:nvSpPr>
         <p:spPr>
           <a:xfrm>
-            <a:off x="8915400" y="2057400"/>
-            <a:ext cx="2606040" cy="758952"/>
+            <a:off x="8915400" y="2011680"/>
+            <a:ext cx="2606040" cy="850392"/>
           </a:xfrm>
           <a:prstGeom prst="rect">
             <a:avLst/>
@@ -1764,14 +1760,14 @@
               <a:buNone/>
             </a:pPr>
             <a:r>
-              <a:rPr lang="en-US" sz="1200" dirty="0">
-                <a:solidFill>
-                  <a:srgbClr val="14353E"/>
-                </a:solidFill>
-              </a:rPr>
-              <a:t>A focused demonstration using fictional accounts and data.</a:t>
-            </a:r>
-            <a:endParaRPr lang="en-US" sz="1200" dirty="0"/>
+              <a:rPr lang="en-US" sz="1250" dirty="0">
+                <a:solidFill>
+                  <a:srgbClr val="0A0A0A"/>
+                </a:solidFill>
+              </a:rPr>
+              <a:t>Four fictional accounts cover the PM, two scientists, and reviewer.</a:t>
+            </a:r>
+            <a:endParaRPr lang="en-US" sz="1250" dirty="0"/>
           </a:p>
         </p:txBody>
       </p:sp>
@@ -1783,18 +1779,18 @@
         </p:nvSpPr>
         <p:spPr>
           <a:xfrm>
-            <a:off x="8695944" y="3118104"/>
-            <a:ext cx="91440" cy="91440"/>
-          </a:xfrm>
-          <a:prstGeom prst="ellipse">
-            <a:avLst/>
-          </a:prstGeom>
-          <a:solidFill>
-            <a:srgbClr val="087E73"/>
+            <a:off x="8695944" y="3300984"/>
+            <a:ext cx="73152" cy="73152"/>
+          </a:xfrm>
+          <a:prstGeom prst="rect">
+            <a:avLst/>
+          </a:prstGeom>
+          <a:solidFill>
+            <a:srgbClr val="4338CA"/>
           </a:solidFill>
           <a:ln w="12700">
             <a:solidFill>
-              <a:srgbClr val="087E73"/>
+              <a:srgbClr val="4338CA"/>
             </a:solidFill>
             <a:prstDash val="solid"/>
           </a:ln>
@@ -1808,8 +1804,8 @@
         </p:nvSpPr>
         <p:spPr>
           <a:xfrm>
-            <a:off x="8915400" y="3063240"/>
-            <a:ext cx="2606040" cy="758952"/>
+            <a:off x="8915400" y="3246120"/>
+            <a:ext cx="2606040" cy="850392"/>
           </a:xfrm>
           <a:prstGeom prst="rect">
             <a:avLst/>
@@ -1827,14 +1823,14 @@
               <a:buNone/>
             </a:pPr>
             <a:r>
-              <a:rPr lang="en-US" sz="1200" dirty="0">
-                <a:solidFill>
-                  <a:srgbClr val="14353E"/>
-                </a:solidFill>
-              </a:rPr>
-              <a:t>Four accounts cover PM, scientist, and reviewer views.</a:t>
-            </a:r>
-            <a:endParaRPr lang="en-US" sz="1200" dirty="0"/>
+              <a:rPr lang="en-US" sz="1250" dirty="0">
+                <a:solidFill>
+                  <a:srgbClr val="0A0A0A"/>
+                </a:solidFill>
+              </a:rPr>
+              <a:t>The login page includes the public demo password.</a:t>
+            </a:r>
+            <a:endParaRPr lang="en-US" sz="1250" dirty="0"/>
           </a:p>
         </p:txBody>
       </p:sp>
@@ -1846,18 +1842,18 @@
         </p:nvSpPr>
         <p:spPr>
           <a:xfrm>
-            <a:off x="8695944" y="4123944"/>
-            <a:ext cx="91440" cy="91440"/>
-          </a:xfrm>
-          <a:prstGeom prst="ellipse">
-            <a:avLst/>
-          </a:prstGeom>
-          <a:solidFill>
-            <a:srgbClr val="087E73"/>
+            <a:off x="8695944" y="4535424"/>
+            <a:ext cx="73152" cy="73152"/>
+          </a:xfrm>
+          <a:prstGeom prst="rect">
+            <a:avLst/>
+          </a:prstGeom>
+          <a:solidFill>
+            <a:srgbClr val="4338CA"/>
           </a:solidFill>
           <a:ln w="12700">
             <a:solidFill>
-              <a:srgbClr val="087E73"/>
+              <a:srgbClr val="4338CA"/>
             </a:solidFill>
             <a:prstDash val="solid"/>
           </a:ln>
@@ -1871,8 +1867,8 @@
         </p:nvSpPr>
         <p:spPr>
           <a:xfrm>
-            <a:off x="8915400" y="4069080"/>
-            <a:ext cx="2606040" cy="758952"/>
+            <a:off x="8915400" y="4480560"/>
+            <a:ext cx="2606040" cy="850392"/>
           </a:xfrm>
           <a:prstGeom prst="rect">
             <a:avLst/>
@@ -1890,14 +1886,14 @@
               <a:buNone/>
             </a:pPr>
             <a:r>
-              <a:rPr lang="en-US" sz="1200" dirty="0">
-                <a:solidFill>
-                  <a:srgbClr val="14353E"/>
-                </a:solidFill>
-              </a:rPr>
-              <a:t>Apex and Windchill integration remain outside this pilot.</a:t>
-            </a:r>
-            <a:endParaRPr lang="en-US" sz="1200" dirty="0"/>
+              <a:rPr lang="en-US" sz="1250" dirty="0">
+                <a:solidFill>
+                  <a:srgbClr val="0A0A0A"/>
+                </a:solidFill>
+              </a:rPr>
+              <a:t>One Vercel project hosts the interface and API.</a:t>
+            </a:r>
+            <a:endParaRPr lang="en-US" sz="1250" dirty="0"/>
           </a:p>
         </p:txBody>
       </p:sp>
@@ -1909,7 +1905,7 @@
         </p:nvSpPr>
         <p:spPr>
           <a:xfrm>
-            <a:off x="457200" y="6547104"/>
+            <a:off x="411480" y="6519672"/>
             <a:ext cx="4114800" cy="182880"/>
           </a:xfrm>
           <a:prstGeom prst="rect">
@@ -1928,10 +1924,10 @@
             <a:r>
               <a:rPr lang="en-US" sz="800" b="1" spc="100" kern="0" dirty="0">
                 <a:solidFill>
-                  <a:srgbClr val="087E73"/>
-                </a:solidFill>
-              </a:rPr>
-              <a:t>FICTIONAL DATA · PILOT DEMO</a:t>
+                  <a:srgbClr val="52525B"/>
+                </a:solidFill>
+              </a:rPr>
+              <a:t>FICTIONAL DATA  /  OCT 2026</a:t>
             </a:r>
             <a:endParaRPr lang="en-US" sz="800" dirty="0"/>
           </a:p>
@@ -1945,8 +1941,8 @@
         </p:nvSpPr>
         <p:spPr>
           <a:xfrm>
-            <a:off x="11155680" y="6510528"/>
-            <a:ext cx="548640" cy="228600"/>
+            <a:off x="11018520" y="6510528"/>
+            <a:ext cx="685800" cy="228600"/>
           </a:xfrm>
           <a:prstGeom prst="rect">
             <a:avLst/>
@@ -1964,10 +1960,10 @@
             <a:r>
               <a:rPr lang="en-US" sz="900" dirty="0">
                 <a:solidFill>
-                  <a:srgbClr val="607984"/>
-                </a:solidFill>
-              </a:rPr>
-              <a:t>01</a:t>
+                  <a:srgbClr val="52525B"/>
+                </a:solidFill>
+              </a:rPr>
+              <a:t>01 / 08</a:t>
             </a:r>
             <a:endParaRPr lang="en-US" sz="900" dirty="0"/>
           </a:p>
@@ -1987,7 +1983,7 @@
     <p:bg>
       <p:bgPr>
         <a:solidFill>
-          <a:srgbClr val="F6F9F9"/>
+          <a:srgbClr val="FAFAFA"/>
         </a:solidFill>
       </p:bgPr>
     </p:bg>
@@ -2014,17 +2010,17 @@
         <p:spPr>
           <a:xfrm>
             <a:off x="0" y="0"/>
-            <a:ext cx="12191695" cy="146304"/>
-          </a:xfrm>
-          <a:prstGeom prst="rect">
-            <a:avLst/>
-          </a:prstGeom>
-          <a:solidFill>
-            <a:srgbClr val="087E73"/>
+            <a:ext cx="109728" cy="6858000"/>
+          </a:xfrm>
+          <a:prstGeom prst="rect">
+            <a:avLst/>
+          </a:prstGeom>
+          <a:solidFill>
+            <a:srgbClr val="4338CA"/>
           </a:solidFill>
           <a:ln w="12700">
             <a:solidFill>
-              <a:srgbClr val="087E73"/>
+              <a:srgbClr val="4338CA"/>
             </a:solidFill>
             <a:prstDash val="solid"/>
           </a:ln>
@@ -2038,8 +2034,8 @@
         </p:nvSpPr>
         <p:spPr>
           <a:xfrm>
-            <a:off x="438912" y="310896"/>
-            <a:ext cx="11064240" cy="384048"/>
+            <a:off x="411480" y="274320"/>
+            <a:ext cx="9144000" cy="182880"/>
           </a:xfrm>
           <a:prstGeom prst="rect">
             <a:avLst/>
@@ -2055,53 +2051,53 @@
               <a:buNone/>
             </a:pPr>
             <a:r>
-              <a:rPr lang="en-US" sz="2500" b="1" dirty="0">
-                <a:solidFill>
-                  <a:srgbClr val="14353E"/>
+              <a:rPr lang="en-US" sz="800" b="1" spc="180" kern="0" dirty="0">
+                <a:solidFill>
+                  <a:srgbClr val="4338CA"/>
+                </a:solidFill>
+              </a:rPr>
+              <a:t>PROJECT MANAGER</a:t>
+            </a:r>
+            <a:endParaRPr lang="en-US" sz="800" dirty="0"/>
+          </a:p>
+        </p:txBody>
+      </p:sp>
+      <p:sp>
+        <p:nvSpPr>
+          <p:cNvPr id="4" name="Text 2"/>
+          <p:cNvSpPr/>
+          <p:nvPr/>
+        </p:nvSpPr>
+        <p:spPr>
+          <a:xfrm>
+            <a:off x="411480" y="530352"/>
+            <a:ext cx="11064240" cy="457200"/>
+          </a:xfrm>
+          <a:prstGeom prst="rect">
+            <a:avLst/>
+          </a:prstGeom>
+          <a:noFill/>
+          <a:ln/>
+        </p:spPr>
+        <p:txBody>
+          <a:bodyPr wrap="square" lIns="0" tIns="0" rIns="0" bIns="0" rtlCol="0" anchor="ctr"/>
+          <a:lstStyle/>
+          <a:p>
+            <a:pPr indent="0" marL="0">
+              <a:buNone/>
+            </a:pPr>
+            <a:r>
+              <a:rPr lang="en-US" sz="2800" b="1" dirty="0">
+                <a:solidFill>
+                  <a:srgbClr val="0A0A0A"/>
                 </a:solidFill>
                 <a:latin typeface="Aptos Display" pitchFamily="34" charset="0"/>
                 <a:ea typeface="Aptos Display" pitchFamily="34" charset="-122"/>
                 <a:cs typeface="Aptos Display" pitchFamily="34" charset="-120"/>
               </a:rPr>
-              <a:t>Live project overview</a:t>
-            </a:r>
-            <a:endParaRPr lang="en-US" sz="2500" dirty="0"/>
-          </a:p>
-        </p:txBody>
-      </p:sp>
-      <p:sp>
-        <p:nvSpPr>
-          <p:cNvPr id="4" name="Text 2"/>
-          <p:cNvSpPr/>
-          <p:nvPr/>
-        </p:nvSpPr>
-        <p:spPr>
-          <a:xfrm>
-            <a:off x="457200" y="758952"/>
-            <a:ext cx="10972800" cy="292608"/>
-          </a:xfrm>
-          <a:prstGeom prst="rect">
-            <a:avLst/>
-          </a:prstGeom>
-          <a:noFill/>
-          <a:ln/>
-        </p:spPr>
-        <p:txBody>
-          <a:bodyPr wrap="square" lIns="0" tIns="0" rIns="0" bIns="0" rtlCol="0" anchor="ctr"/>
-          <a:lstStyle/>
-          <a:p>
-            <a:pPr indent="0" marL="0">
-              <a:buNone/>
-            </a:pPr>
-            <a:r>
-              <a:rPr lang="en-US" sz="1050" dirty="0">
-                <a:solidFill>
-                  <a:srgbClr val="607984"/>
-                </a:solidFill>
-              </a:rPr>
-              <a:t>Project Manager view</a:t>
-            </a:r>
-            <a:endParaRPr lang="en-US" sz="1050" dirty="0"/>
+              <a:t>Project overview</a:t>
+            </a:r>
+            <a:endParaRPr lang="en-US" sz="2800" dirty="0"/>
           </a:p>
         </p:txBody>
       </p:sp>
@@ -2113,20 +2109,18 @@
         </p:nvSpPr>
         <p:spPr>
           <a:xfrm>
-            <a:off x="365760" y="1243584"/>
-            <a:ext cx="7818120" cy="5010912"/>
-          </a:xfrm>
-          <a:prstGeom prst="roundRect">
-            <a:avLst>
-              <a:gd name="adj" fmla="val 1825"/>
-            </a:avLst>
+            <a:off x="365760" y="1207008"/>
+            <a:ext cx="7818120" cy="5029200"/>
+          </a:xfrm>
+          <a:prstGeom prst="rect">
+            <a:avLst/>
           </a:prstGeom>
           <a:solidFill>
             <a:srgbClr val="FFFFFF"/>
           </a:solidFill>
           <a:ln w="12700">
             <a:solidFill>
-              <a:srgbClr val="DCE8E8"/>
+              <a:srgbClr val="E4E4E7"/>
             </a:solidFill>
             <a:prstDash val="solid"/>
           </a:ln>
@@ -2148,8 +2142,8 @@
         </p:blipFill>
         <p:spPr>
           <a:xfrm>
-            <a:off x="411480" y="1289304"/>
-            <a:ext cx="7726680" cy="4919472"/>
+            <a:off x="402336" y="1243584"/>
+            <a:ext cx="7744968" cy="4956048"/>
           </a:xfrm>
           <a:prstGeom prst="rect">
             <a:avLst/>
@@ -2164,20 +2158,18 @@
         </p:nvSpPr>
         <p:spPr>
           <a:xfrm>
-            <a:off x="8439912" y="1243584"/>
-            <a:ext cx="3364992" cy="5010912"/>
-          </a:xfrm>
-          <a:prstGeom prst="roundRect">
-            <a:avLst>
-              <a:gd name="adj" fmla="val 2717"/>
-            </a:avLst>
+            <a:off x="8439912" y="1207008"/>
+            <a:ext cx="3364992" cy="5029200"/>
+          </a:xfrm>
+          <a:prstGeom prst="rect">
+            <a:avLst/>
           </a:prstGeom>
           <a:solidFill>
             <a:srgbClr val="FFFFFF"/>
           </a:solidFill>
           <a:ln w="12700">
             <a:solidFill>
-              <a:srgbClr val="DCE8E8"/>
+              <a:srgbClr val="E4E4E7"/>
             </a:solidFill>
             <a:prstDash val="solid"/>
           </a:ln>
@@ -2191,8 +2183,8 @@
         </p:nvSpPr>
         <p:spPr>
           <a:xfrm>
-            <a:off x="8686800" y="1536192"/>
-            <a:ext cx="2834640" cy="320040"/>
+            <a:off x="8686800" y="1545336"/>
+            <a:ext cx="2834640" cy="210312"/>
           </a:xfrm>
           <a:prstGeom prst="rect">
             <a:avLst/>
@@ -2208,14 +2200,14 @@
               <a:buNone/>
             </a:pPr>
             <a:r>
-              <a:rPr lang="en-US" sz="1500" b="1" dirty="0">
-                <a:solidFill>
-                  <a:srgbClr val="14353E"/>
-                </a:solidFill>
-              </a:rPr>
-              <a:t>What this shows</a:t>
-            </a:r>
-            <a:endParaRPr lang="en-US" sz="1500" dirty="0"/>
+              <a:rPr lang="en-US" sz="900" b="1" spc="160" kern="0" dirty="0">
+                <a:solidFill>
+                  <a:srgbClr val="4338CA"/>
+                </a:solidFill>
+              </a:rPr>
+              <a:t>IN THIS VIEW</a:t>
+            </a:r>
+            <a:endParaRPr lang="en-US" sz="900" dirty="0"/>
           </a:p>
         </p:txBody>
       </p:sp>
@@ -2227,18 +2219,18 @@
         </p:nvSpPr>
         <p:spPr>
           <a:xfrm>
-            <a:off x="8695944" y="2112264"/>
-            <a:ext cx="91440" cy="91440"/>
-          </a:xfrm>
-          <a:prstGeom prst="ellipse">
-            <a:avLst/>
-          </a:prstGeom>
-          <a:solidFill>
-            <a:srgbClr val="087E73"/>
+            <a:off x="8695944" y="2066544"/>
+            <a:ext cx="73152" cy="73152"/>
+          </a:xfrm>
+          <a:prstGeom prst="rect">
+            <a:avLst/>
+          </a:prstGeom>
+          <a:solidFill>
+            <a:srgbClr val="4338CA"/>
           </a:solidFill>
           <a:ln w="12700">
             <a:solidFill>
-              <a:srgbClr val="087E73"/>
+              <a:srgbClr val="4338CA"/>
             </a:solidFill>
             <a:prstDash val="solid"/>
           </a:ln>
@@ -2252,8 +2244,8 @@
         </p:nvSpPr>
         <p:spPr>
           <a:xfrm>
-            <a:off x="8915400" y="2057400"/>
-            <a:ext cx="2606040" cy="758952"/>
+            <a:off x="8915400" y="2011680"/>
+            <a:ext cx="2606040" cy="850392"/>
           </a:xfrm>
           <a:prstGeom prst="rect">
             <a:avLst/>
@@ -2271,14 +2263,14 @@
               <a:buNone/>
             </a:pPr>
             <a:r>
-              <a:rPr lang="en-US" sz="1200" dirty="0">
-                <a:solidFill>
-                  <a:srgbClr val="14353E"/>
-                </a:solidFill>
-              </a:rPr>
-              <a:t>Dashboard totals come from the current database.</a:t>
-            </a:r>
-            <a:endParaRPr lang="en-US" sz="1200" dirty="0"/>
+              <a:rPr lang="en-US" sz="1250" dirty="0">
+                <a:solidFill>
+                  <a:srgbClr val="0A0A0A"/>
+                </a:solidFill>
+              </a:rPr>
+              <a:t>Dashboard totals come from current task and approval data.</a:t>
+            </a:r>
+            <a:endParaRPr lang="en-US" sz="1250" dirty="0"/>
           </a:p>
         </p:txBody>
       </p:sp>
@@ -2290,18 +2282,18 @@
         </p:nvSpPr>
         <p:spPr>
           <a:xfrm>
-            <a:off x="8695944" y="3118104"/>
-            <a:ext cx="91440" cy="91440"/>
-          </a:xfrm>
-          <a:prstGeom prst="ellipse">
-            <a:avLst/>
-          </a:prstGeom>
-          <a:solidFill>
-            <a:srgbClr val="087E73"/>
+            <a:off x="8695944" y="3300984"/>
+            <a:ext cx="73152" cy="73152"/>
+          </a:xfrm>
+          <a:prstGeom prst="rect">
+            <a:avLst/>
+          </a:prstGeom>
+          <a:solidFill>
+            <a:srgbClr val="4338CA"/>
           </a:solidFill>
           <a:ln w="12700">
             <a:solidFill>
-              <a:srgbClr val="087E73"/>
+              <a:srgbClr val="4338CA"/>
             </a:solidFill>
             <a:prstDash val="solid"/>
           </a:ln>
@@ -2315,8 +2307,8 @@
         </p:nvSpPr>
         <p:spPr>
           <a:xfrm>
-            <a:off x="8915400" y="3063240"/>
-            <a:ext cx="2606040" cy="758952"/>
+            <a:off x="8915400" y="3246120"/>
+            <a:ext cx="2606040" cy="850392"/>
           </a:xfrm>
           <a:prstGeom prst="rect">
             <a:avLst/>
@@ -2334,14 +2326,14 @@
               <a:buNone/>
             </a:pPr>
             <a:r>
-              <a:rPr lang="en-US" sz="1200" dirty="0">
-                <a:solidFill>
-                  <a:srgbClr val="14353E"/>
-                </a:solidFill>
-              </a:rPr>
-              <a:t>Tasks show owner, status, priority, due date, and overdue work.</a:t>
-            </a:r>
-            <a:endParaRPr lang="en-US" sz="1200" dirty="0"/>
+              <a:rPr lang="en-US" sz="1250" dirty="0">
+                <a:solidFill>
+                  <a:srgbClr val="0A0A0A"/>
+                </a:solidFill>
+              </a:rPr>
+              <a:t>Seventeen seeded tasks cover varied owners and deadlines.</a:t>
+            </a:r>
+            <a:endParaRPr lang="en-US" sz="1250" dirty="0"/>
           </a:p>
         </p:txBody>
       </p:sp>
@@ -2353,18 +2345,18 @@
         </p:nvSpPr>
         <p:spPr>
           <a:xfrm>
-            <a:off x="8695944" y="4123944"/>
-            <a:ext cx="91440" cy="91440"/>
-          </a:xfrm>
-          <a:prstGeom prst="ellipse">
-            <a:avLst/>
-          </a:prstGeom>
-          <a:solidFill>
-            <a:srgbClr val="087E73"/>
+            <a:off x="8695944" y="4535424"/>
+            <a:ext cx="73152" cy="73152"/>
+          </a:xfrm>
+          <a:prstGeom prst="rect">
+            <a:avLst/>
+          </a:prstGeom>
+          <a:solidFill>
+            <a:srgbClr val="4338CA"/>
           </a:solidFill>
           <a:ln w="12700">
             <a:solidFill>
-              <a:srgbClr val="087E73"/>
+              <a:srgbClr val="4338CA"/>
             </a:solidFill>
             <a:prstDash val="solid"/>
           </a:ln>
@@ -2378,8 +2370,8 @@
         </p:nvSpPr>
         <p:spPr>
           <a:xfrm>
-            <a:off x="8915400" y="4069080"/>
-            <a:ext cx="2606040" cy="758952"/>
+            <a:off x="8915400" y="4480560"/>
+            <a:ext cx="2606040" cy="850392"/>
           </a:xfrm>
           <a:prstGeom prst="rect">
             <a:avLst/>
@@ -2397,14 +2389,14 @@
               <a:buNone/>
             </a:pPr>
             <a:r>
-              <a:rPr lang="en-US" sz="1200" dirty="0">
-                <a:solidFill>
-                  <a:srgbClr val="14353E"/>
-                </a:solidFill>
-              </a:rPr>
-              <a:t>One reset restores a predictable demonstration picture.</a:t>
-            </a:r>
-            <a:endParaRPr lang="en-US" sz="1200" dirty="0"/>
+              <a:rPr lang="en-US" sz="1250" dirty="0">
+                <a:solidFill>
+                  <a:srgbClr val="0A0A0A"/>
+                </a:solidFill>
+              </a:rPr>
+              <a:t>Decision and overdue lists lead to the underlying work.</a:t>
+            </a:r>
+            <a:endParaRPr lang="en-US" sz="1250" dirty="0"/>
           </a:p>
         </p:txBody>
       </p:sp>
@@ -2416,7 +2408,7 @@
         </p:nvSpPr>
         <p:spPr>
           <a:xfrm>
-            <a:off x="457200" y="6547104"/>
+            <a:off x="411480" y="6519672"/>
             <a:ext cx="4114800" cy="182880"/>
           </a:xfrm>
           <a:prstGeom prst="rect">
@@ -2435,10 +2427,10 @@
             <a:r>
               <a:rPr lang="en-US" sz="800" b="1" spc="100" kern="0" dirty="0">
                 <a:solidFill>
-                  <a:srgbClr val="087E73"/>
-                </a:solidFill>
-              </a:rPr>
-              <a:t>FICTIONAL DATA · PILOT DEMO</a:t>
+                  <a:srgbClr val="52525B"/>
+                </a:solidFill>
+              </a:rPr>
+              <a:t>FICTIONAL DATA  /  OCT 2026</a:t>
             </a:r>
             <a:endParaRPr lang="en-US" sz="800" dirty="0"/>
           </a:p>
@@ -2452,8 +2444,8 @@
         </p:nvSpPr>
         <p:spPr>
           <a:xfrm>
-            <a:off x="11155680" y="6510528"/>
-            <a:ext cx="548640" cy="228600"/>
+            <a:off x="11018520" y="6510528"/>
+            <a:ext cx="685800" cy="228600"/>
           </a:xfrm>
           <a:prstGeom prst="rect">
             <a:avLst/>
@@ -2471,10 +2463,10 @@
             <a:r>
               <a:rPr lang="en-US" sz="900" dirty="0">
                 <a:solidFill>
-                  <a:srgbClr val="607984"/>
-                </a:solidFill>
-              </a:rPr>
-              <a:t>02</a:t>
+                  <a:srgbClr val="52525B"/>
+                </a:solidFill>
+              </a:rPr>
+              <a:t>02 / 08</a:t>
             </a:r>
             <a:endParaRPr lang="en-US" sz="900" dirty="0"/>
           </a:p>
@@ -2494,7 +2486,7 @@
     <p:bg>
       <p:bgPr>
         <a:solidFill>
-          <a:srgbClr val="F6F9F9"/>
+          <a:srgbClr val="FAFAFA"/>
         </a:solidFill>
       </p:bgPr>
     </p:bg>
@@ -2521,17 +2513,17 @@
         <p:spPr>
           <a:xfrm>
             <a:off x="0" y="0"/>
-            <a:ext cx="12191695" cy="146304"/>
-          </a:xfrm>
-          <a:prstGeom prst="rect">
-            <a:avLst/>
-          </a:prstGeom>
-          <a:solidFill>
-            <a:srgbClr val="087E73"/>
+            <a:ext cx="109728" cy="6858000"/>
+          </a:xfrm>
+          <a:prstGeom prst="rect">
+            <a:avLst/>
+          </a:prstGeom>
+          <a:solidFill>
+            <a:srgbClr val="4338CA"/>
           </a:solidFill>
           <a:ln w="12700">
             <a:solidFill>
-              <a:srgbClr val="087E73"/>
+              <a:srgbClr val="4338CA"/>
             </a:solidFill>
             <a:prstDash val="solid"/>
           </a:ln>
@@ -2545,8 +2537,8 @@
         </p:nvSpPr>
         <p:spPr>
           <a:xfrm>
-            <a:off x="438912" y="310896"/>
-            <a:ext cx="11064240" cy="384048"/>
+            <a:off x="411480" y="274320"/>
+            <a:ext cx="9144000" cy="182880"/>
           </a:xfrm>
           <a:prstGeom prst="rect">
             <a:avLst/>
@@ -2562,53 +2554,53 @@
               <a:buNone/>
             </a:pPr>
             <a:r>
-              <a:rPr lang="en-US" sz="2500" b="1" dirty="0">
-                <a:solidFill>
-                  <a:srgbClr val="14353E"/>
+              <a:rPr lang="en-US" sz="800" b="1" spc="180" kern="0" dirty="0">
+                <a:solidFill>
+                  <a:srgbClr val="4338CA"/>
+                </a:solidFill>
+              </a:rPr>
+              <a:t>PROJECT MANAGER</a:t>
+            </a:r>
+            <a:endParaRPr lang="en-US" sz="800" dirty="0"/>
+          </a:p>
+        </p:txBody>
+      </p:sp>
+      <p:sp>
+        <p:nvSpPr>
+          <p:cNvPr id="4" name="Text 2"/>
+          <p:cNvSpPr/>
+          <p:nvPr/>
+        </p:nvSpPr>
+        <p:spPr>
+          <a:xfrm>
+            <a:off x="411480" y="530352"/>
+            <a:ext cx="11064240" cy="457200"/>
+          </a:xfrm>
+          <a:prstGeom prst="rect">
+            <a:avLst/>
+          </a:prstGeom>
+          <a:noFill/>
+          <a:ln/>
+        </p:spPr>
+        <p:txBody>
+          <a:bodyPr wrap="square" lIns="0" tIns="0" rIns="0" bIns="0" rtlCol="0" anchor="ctr"/>
+          <a:lstStyle/>
+          <a:p>
+            <a:pPr indent="0" marL="0">
+              <a:buNone/>
+            </a:pPr>
+            <a:r>
+              <a:rPr lang="en-US" sz="2800" b="1" dirty="0">
+                <a:solidFill>
+                  <a:srgbClr val="0A0A0A"/>
                 </a:solidFill>
                 <a:latin typeface="Aptos Display" pitchFamily="34" charset="0"/>
                 <a:ea typeface="Aptos Display" pitchFamily="34" charset="-122"/>
                 <a:cs typeface="Aptos Display" pitchFamily="34" charset="-120"/>
               </a:rPr>
-              <a:t>Project planning and groups</a:t>
-            </a:r>
-            <a:endParaRPr lang="en-US" sz="2500" dirty="0"/>
-          </a:p>
-        </p:txBody>
-      </p:sp>
-      <p:sp>
-        <p:nvSpPr>
-          <p:cNvPr id="4" name="Text 2"/>
-          <p:cNvSpPr/>
-          <p:nvPr/>
-        </p:nvSpPr>
-        <p:spPr>
-          <a:xfrm>
-            <a:off x="457200" y="758952"/>
-            <a:ext cx="10972800" cy="292608"/>
-          </a:xfrm>
-          <a:prstGeom prst="rect">
-            <a:avLst/>
-          </a:prstGeom>
-          <a:noFill/>
-          <a:ln/>
-        </p:spPr>
-        <p:txBody>
-          <a:bodyPr wrap="square" lIns="0" tIns="0" rIns="0" bIns="0" rtlCol="0" anchor="ctr"/>
-          <a:lstStyle/>
-          <a:p>
-            <a:pPr indent="0" marL="0">
-              <a:buNone/>
-            </a:pPr>
-            <a:r>
-              <a:rPr lang="en-US" sz="1050" dirty="0">
-                <a:solidFill>
-                  <a:srgbClr val="607984"/>
-                </a:solidFill>
-              </a:rPr>
-              <a:t>Project Manager view</a:t>
-            </a:r>
-            <a:endParaRPr lang="en-US" sz="1050" dirty="0"/>
+              <a:t>Projects and controlled sharing</a:t>
+            </a:r>
+            <a:endParaRPr lang="en-US" sz="2800" dirty="0"/>
           </a:p>
         </p:txBody>
       </p:sp>
@@ -2620,20 +2612,18 @@
         </p:nvSpPr>
         <p:spPr>
           <a:xfrm>
-            <a:off x="365760" y="1243584"/>
-            <a:ext cx="7818120" cy="5010912"/>
-          </a:xfrm>
-          <a:prstGeom prst="roundRect">
-            <a:avLst>
-              <a:gd name="adj" fmla="val 1825"/>
-            </a:avLst>
+            <a:off x="365760" y="1207008"/>
+            <a:ext cx="7818120" cy="5029200"/>
+          </a:xfrm>
+          <a:prstGeom prst="rect">
+            <a:avLst/>
           </a:prstGeom>
           <a:solidFill>
             <a:srgbClr val="FFFFFF"/>
           </a:solidFill>
           <a:ln w="12700">
             <a:solidFill>
-              <a:srgbClr val="DCE8E8"/>
+              <a:srgbClr val="E4E4E7"/>
             </a:solidFill>
             <a:prstDash val="solid"/>
           </a:ln>
@@ -2655,8 +2645,8 @@
         </p:blipFill>
         <p:spPr>
           <a:xfrm>
-            <a:off x="411480" y="1289304"/>
-            <a:ext cx="7726680" cy="4919472"/>
+            <a:off x="402336" y="1243584"/>
+            <a:ext cx="7744968" cy="4956048"/>
           </a:xfrm>
           <a:prstGeom prst="rect">
             <a:avLst/>
@@ -2671,20 +2661,18 @@
         </p:nvSpPr>
         <p:spPr>
           <a:xfrm>
-            <a:off x="8439912" y="1243584"/>
-            <a:ext cx="3364992" cy="5010912"/>
-          </a:xfrm>
-          <a:prstGeom prst="roundRect">
-            <a:avLst>
-              <a:gd name="adj" fmla="val 2717"/>
-            </a:avLst>
+            <a:off x="8439912" y="1207008"/>
+            <a:ext cx="3364992" cy="5029200"/>
+          </a:xfrm>
+          <a:prstGeom prst="rect">
+            <a:avLst/>
           </a:prstGeom>
           <a:solidFill>
             <a:srgbClr val="FFFFFF"/>
           </a:solidFill>
           <a:ln w="12700">
             <a:solidFill>
-              <a:srgbClr val="DCE8E8"/>
+              <a:srgbClr val="E4E4E7"/>
             </a:solidFill>
             <a:prstDash val="solid"/>
           </a:ln>
@@ -2698,8 +2686,8 @@
         </p:nvSpPr>
         <p:spPr>
           <a:xfrm>
-            <a:off x="8686800" y="1536192"/>
-            <a:ext cx="2834640" cy="320040"/>
+            <a:off x="8686800" y="1545336"/>
+            <a:ext cx="2834640" cy="210312"/>
           </a:xfrm>
           <a:prstGeom prst="rect">
             <a:avLst/>
@@ -2715,14 +2703,14 @@
               <a:buNone/>
             </a:pPr>
             <a:r>
-              <a:rPr lang="en-US" sz="1500" b="1" dirty="0">
-                <a:solidFill>
-                  <a:srgbClr val="14353E"/>
-                </a:solidFill>
-              </a:rPr>
-              <a:t>What this shows</a:t>
-            </a:r>
-            <a:endParaRPr lang="en-US" sz="1500" dirty="0"/>
+              <a:rPr lang="en-US" sz="900" b="1" spc="160" kern="0" dirty="0">
+                <a:solidFill>
+                  <a:srgbClr val="4338CA"/>
+                </a:solidFill>
+              </a:rPr>
+              <a:t>IN THIS VIEW</a:t>
+            </a:r>
+            <a:endParaRPr lang="en-US" sz="900" dirty="0"/>
           </a:p>
         </p:txBody>
       </p:sp>
@@ -2734,18 +2722,18 @@
         </p:nvSpPr>
         <p:spPr>
           <a:xfrm>
-            <a:off x="8695944" y="2112264"/>
-            <a:ext cx="91440" cy="91440"/>
-          </a:xfrm>
-          <a:prstGeom prst="ellipse">
-            <a:avLst/>
-          </a:prstGeom>
-          <a:solidFill>
-            <a:srgbClr val="087E73"/>
+            <a:off x="8695944" y="2066544"/>
+            <a:ext cx="73152" cy="73152"/>
+          </a:xfrm>
+          <a:prstGeom prst="rect">
+            <a:avLst/>
+          </a:prstGeom>
+          <a:solidFill>
+            <a:srgbClr val="4338CA"/>
           </a:solidFill>
           <a:ln w="12700">
             <a:solidFill>
-              <a:srgbClr val="087E73"/>
+              <a:srgbClr val="4338CA"/>
             </a:solidFill>
             <a:prstDash val="solid"/>
           </a:ln>
@@ -2759,8 +2747,8 @@
         </p:nvSpPr>
         <p:spPr>
           <a:xfrm>
-            <a:off x="8915400" y="2057400"/>
-            <a:ext cx="2606040" cy="758952"/>
+            <a:off x="8915400" y="2011680"/>
+            <a:ext cx="2606040" cy="850392"/>
           </a:xfrm>
           <a:prstGeom prst="rect">
             <a:avLst/>
@@ -2778,14 +2766,14 @@
               <a:buNone/>
             </a:pPr>
             <a:r>
-              <a:rPr lang="en-US" sz="1200" dirty="0">
-                <a:solidFill>
-                  <a:srgbClr val="14353E"/>
+              <a:rPr lang="en-US" sz="1250" dirty="0">
+                <a:solidFill>
+                  <a:srgbClr val="0A0A0A"/>
                 </a:solidFill>
               </a:rPr>
               <a:t>Create projects, parent tasks, and assigned work.</a:t>
             </a:r>
-            <a:endParaRPr lang="en-US" sz="1200" dirty="0"/>
+            <a:endParaRPr lang="en-US" sz="1250" dirty="0"/>
           </a:p>
         </p:txBody>
       </p:sp>
@@ -2797,18 +2785,18 @@
         </p:nvSpPr>
         <p:spPr>
           <a:xfrm>
-            <a:off x="8695944" y="3118104"/>
-            <a:ext cx="91440" cy="91440"/>
-          </a:xfrm>
-          <a:prstGeom prst="ellipse">
-            <a:avLst/>
-          </a:prstGeom>
-          <a:solidFill>
-            <a:srgbClr val="087E73"/>
+            <a:off x="8695944" y="3300984"/>
+            <a:ext cx="73152" cy="73152"/>
+          </a:xfrm>
+          <a:prstGeom prst="rect">
+            <a:avLst/>
+          </a:prstGeom>
+          <a:solidFill>
+            <a:srgbClr val="4338CA"/>
           </a:solidFill>
           <a:ln w="12700">
             <a:solidFill>
-              <a:srgbClr val="087E73"/>
+              <a:srgbClr val="4338CA"/>
             </a:solidFill>
             <a:prstDash val="solid"/>
           </a:ln>
@@ -2822,8 +2810,8 @@
         </p:nvSpPr>
         <p:spPr>
           <a:xfrm>
-            <a:off x="8915400" y="3063240"/>
-            <a:ext cx="2606040" cy="758952"/>
+            <a:off x="8915400" y="3246120"/>
+            <a:ext cx="2606040" cy="850392"/>
           </a:xfrm>
           <a:prstGeom prst="rect">
             <a:avLst/>
@@ -2841,14 +2829,14 @@
               <a:buNone/>
             </a:pPr>
             <a:r>
-              <a:rPr lang="en-US" sz="1200" dirty="0">
-                <a:solidFill>
-                  <a:srgbClr val="14353E"/>
-                </a:solidFill>
-              </a:rPr>
-              <a:t>Project groups control sharing and three fixed permissions.</a:t>
-            </a:r>
-            <a:endParaRPr lang="en-US" sz="1200" dirty="0"/>
+              <a:rPr lang="en-US" sz="1250" dirty="0">
+                <a:solidFill>
+                  <a:srgbClr val="0A0A0A"/>
+                </a:solidFill>
+              </a:rPr>
+              <a:t>Groups control member access and task sharing.</a:t>
+            </a:r>
+            <a:endParaRPr lang="en-US" sz="1250" dirty="0"/>
           </a:p>
         </p:txBody>
       </p:sp>
@@ -2860,18 +2848,18 @@
         </p:nvSpPr>
         <p:spPr>
           <a:xfrm>
-            <a:off x="8695944" y="4123944"/>
-            <a:ext cx="91440" cy="91440"/>
-          </a:xfrm>
-          <a:prstGeom prst="ellipse">
-            <a:avLst/>
-          </a:prstGeom>
-          <a:solidFill>
-            <a:srgbClr val="087E73"/>
+            <a:off x="8695944" y="4535424"/>
+            <a:ext cx="73152" cy="73152"/>
+          </a:xfrm>
+          <a:prstGeom prst="rect">
+            <a:avLst/>
+          </a:prstGeom>
+          <a:solidFill>
+            <a:srgbClr val="4338CA"/>
           </a:solidFill>
           <a:ln w="12700">
             <a:solidFill>
-              <a:srgbClr val="087E73"/>
+              <a:srgbClr val="4338CA"/>
             </a:solidFill>
             <a:prstDash val="solid"/>
           </a:ln>
@@ -2885,8 +2873,8 @@
         </p:nvSpPr>
         <p:spPr>
           <a:xfrm>
-            <a:off x="8915400" y="4069080"/>
-            <a:ext cx="2606040" cy="758952"/>
+            <a:off x="8915400" y="4480560"/>
+            <a:ext cx="2606040" cy="850392"/>
           </a:xfrm>
           <a:prstGeom prst="rect">
             <a:avLst/>
@@ -2904,14 +2892,14 @@
               <a:buNone/>
             </a:pPr>
             <a:r>
-              <a:rPr lang="en-US" sz="1200" dirty="0">
-                <a:solidFill>
-                  <a:srgbClr val="14353E"/>
-                </a:solidFill>
-              </a:rPr>
-              <a:t>Members can belong to more than one group.</a:t>
-            </a:r>
-            <a:endParaRPr lang="en-US" sz="1200" dirty="0"/>
+              <a:rPr lang="en-US" sz="1250" dirty="0">
+                <a:solidFill>
+                  <a:srgbClr val="0A0A0A"/>
+                </a:solidFill>
+              </a:rPr>
+              <a:t>Permissions apply to the API as well as the interface.</a:t>
+            </a:r>
+            <a:endParaRPr lang="en-US" sz="1250" dirty="0"/>
           </a:p>
         </p:txBody>
       </p:sp>
@@ -2923,7 +2911,7 @@
         </p:nvSpPr>
         <p:spPr>
           <a:xfrm>
-            <a:off x="457200" y="6547104"/>
+            <a:off x="411480" y="6519672"/>
             <a:ext cx="4114800" cy="182880"/>
           </a:xfrm>
           <a:prstGeom prst="rect">
@@ -2942,10 +2930,10 @@
             <a:r>
               <a:rPr lang="en-US" sz="800" b="1" spc="100" kern="0" dirty="0">
                 <a:solidFill>
-                  <a:srgbClr val="087E73"/>
-                </a:solidFill>
-              </a:rPr>
-              <a:t>FICTIONAL DATA · PILOT DEMO</a:t>
+                  <a:srgbClr val="52525B"/>
+                </a:solidFill>
+              </a:rPr>
+              <a:t>FICTIONAL DATA  /  OCT 2026</a:t>
             </a:r>
             <a:endParaRPr lang="en-US" sz="800" dirty="0"/>
           </a:p>
@@ -2959,8 +2947,8 @@
         </p:nvSpPr>
         <p:spPr>
           <a:xfrm>
-            <a:off x="11155680" y="6510528"/>
-            <a:ext cx="548640" cy="228600"/>
+            <a:off x="11018520" y="6510528"/>
+            <a:ext cx="685800" cy="228600"/>
           </a:xfrm>
           <a:prstGeom prst="rect">
             <a:avLst/>
@@ -2978,10 +2966,10 @@
             <a:r>
               <a:rPr lang="en-US" sz="900" dirty="0">
                 <a:solidFill>
-                  <a:srgbClr val="607984"/>
-                </a:solidFill>
-              </a:rPr>
-              <a:t>03</a:t>
+                  <a:srgbClr val="52525B"/>
+                </a:solidFill>
+              </a:rPr>
+              <a:t>03 / 08</a:t>
             </a:r>
             <a:endParaRPr lang="en-US" sz="900" dirty="0"/>
           </a:p>
@@ -3001,7 +2989,7 @@
     <p:bg>
       <p:bgPr>
         <a:solidFill>
-          <a:srgbClr val="F6F9F9"/>
+          <a:srgbClr val="FAFAFA"/>
         </a:solidFill>
       </p:bgPr>
     </p:bg>
@@ -3028,17 +3016,17 @@
         <p:spPr>
           <a:xfrm>
             <a:off x="0" y="0"/>
-            <a:ext cx="12191695" cy="146304"/>
-          </a:xfrm>
-          <a:prstGeom prst="rect">
-            <a:avLst/>
-          </a:prstGeom>
-          <a:solidFill>
-            <a:srgbClr val="087E73"/>
+            <a:ext cx="109728" cy="6858000"/>
+          </a:xfrm>
+          <a:prstGeom prst="rect">
+            <a:avLst/>
+          </a:prstGeom>
+          <a:solidFill>
+            <a:srgbClr val="4338CA"/>
           </a:solidFill>
           <a:ln w="12700">
             <a:solidFill>
-              <a:srgbClr val="087E73"/>
+              <a:srgbClr val="4338CA"/>
             </a:solidFill>
             <a:prstDash val="solid"/>
           </a:ln>
@@ -3052,8 +3040,8 @@
         </p:nvSpPr>
         <p:spPr>
           <a:xfrm>
-            <a:off x="438912" y="310896"/>
-            <a:ext cx="11064240" cy="384048"/>
+            <a:off x="411480" y="274320"/>
+            <a:ext cx="9144000" cy="182880"/>
           </a:xfrm>
           <a:prstGeom prst="rect">
             <a:avLst/>
@@ -3069,53 +3057,53 @@
               <a:buNone/>
             </a:pPr>
             <a:r>
-              <a:rPr lang="en-US" sz="2500" b="1" dirty="0">
-                <a:solidFill>
-                  <a:srgbClr val="14353E"/>
+              <a:rPr lang="en-US" sz="800" b="1" spc="180" kern="0" dirty="0">
+                <a:solidFill>
+                  <a:srgbClr val="4338CA"/>
+                </a:solidFill>
+              </a:rPr>
+              <a:t>SCIENTIST ONE</a:t>
+            </a:r>
+            <a:endParaRPr lang="en-US" sz="800" dirty="0"/>
+          </a:p>
+        </p:txBody>
+      </p:sp>
+      <p:sp>
+        <p:nvSpPr>
+          <p:cNvPr id="4" name="Text 2"/>
+          <p:cNvSpPr/>
+          <p:nvPr/>
+        </p:nvSpPr>
+        <p:spPr>
+          <a:xfrm>
+            <a:off x="411480" y="530352"/>
+            <a:ext cx="11064240" cy="457200"/>
+          </a:xfrm>
+          <a:prstGeom prst="rect">
+            <a:avLst/>
+          </a:prstGeom>
+          <a:noFill/>
+          <a:ln/>
+        </p:spPr>
+        <p:txBody>
+          <a:bodyPr wrap="square" lIns="0" tIns="0" rIns="0" bIns="0" rtlCol="0" anchor="ctr"/>
+          <a:lstStyle/>
+          <a:p>
+            <a:pPr indent="0" marL="0">
+              <a:buNone/>
+            </a:pPr>
+            <a:r>
+              <a:rPr lang="en-US" sz="2800" b="1" dirty="0">
+                <a:solidFill>
+                  <a:srgbClr val="0A0A0A"/>
                 </a:solidFill>
                 <a:latin typeface="Aptos Display" pitchFamily="34" charset="0"/>
                 <a:ea typeface="Aptos Display" pitchFamily="34" charset="-122"/>
                 <a:cs typeface="Aptos Display" pitchFamily="34" charset="-120"/>
               </a:rPr>
-              <a:t>Scientist task view</a:t>
-            </a:r>
-            <a:endParaRPr lang="en-US" sz="2500" dirty="0"/>
-          </a:p>
-        </p:txBody>
-      </p:sp>
-      <p:sp>
-        <p:nvSpPr>
-          <p:cNvPr id="4" name="Text 2"/>
-          <p:cNvSpPr/>
-          <p:nvPr/>
-        </p:nvSpPr>
-        <p:spPr>
-          <a:xfrm>
-            <a:off x="457200" y="758952"/>
-            <a:ext cx="10972800" cy="292608"/>
-          </a:xfrm>
-          <a:prstGeom prst="rect">
-            <a:avLst/>
-          </a:prstGeom>
-          <a:noFill/>
-          <a:ln/>
-        </p:spPr>
-        <p:txBody>
-          <a:bodyPr wrap="square" lIns="0" tIns="0" rIns="0" bIns="0" rtlCol="0" anchor="ctr"/>
-          <a:lstStyle/>
-          <a:p>
-            <a:pPr indent="0" marL="0">
-              <a:buNone/>
-            </a:pPr>
-            <a:r>
-              <a:rPr lang="en-US" sz="1050" dirty="0">
-                <a:solidFill>
-                  <a:srgbClr val="607984"/>
-                </a:solidFill>
-              </a:rPr>
-              <a:t>Member view</a:t>
-            </a:r>
-            <a:endParaRPr lang="en-US" sz="1050" dirty="0"/>
+              <a:t>Scientist workspace</a:t>
+            </a:r>
+            <a:endParaRPr lang="en-US" sz="2800" dirty="0"/>
           </a:p>
         </p:txBody>
       </p:sp>
@@ -3127,20 +3115,18 @@
         </p:nvSpPr>
         <p:spPr>
           <a:xfrm>
-            <a:off x="365760" y="1243584"/>
-            <a:ext cx="7818120" cy="5010912"/>
-          </a:xfrm>
-          <a:prstGeom prst="roundRect">
-            <a:avLst>
-              <a:gd name="adj" fmla="val 1825"/>
-            </a:avLst>
+            <a:off x="365760" y="1207008"/>
+            <a:ext cx="7818120" cy="5029200"/>
+          </a:xfrm>
+          <a:prstGeom prst="rect">
+            <a:avLst/>
           </a:prstGeom>
           <a:solidFill>
             <a:srgbClr val="FFFFFF"/>
           </a:solidFill>
           <a:ln w="12700">
             <a:solidFill>
-              <a:srgbClr val="DCE8E8"/>
+              <a:srgbClr val="E4E4E7"/>
             </a:solidFill>
             <a:prstDash val="solid"/>
           </a:ln>
@@ -3162,8 +3148,8 @@
         </p:blipFill>
         <p:spPr>
           <a:xfrm>
-            <a:off x="411480" y="1289304"/>
-            <a:ext cx="7726680" cy="4919472"/>
+            <a:off x="402336" y="1243584"/>
+            <a:ext cx="7744968" cy="4956048"/>
           </a:xfrm>
           <a:prstGeom prst="rect">
             <a:avLst/>
@@ -3178,20 +3164,18 @@
         </p:nvSpPr>
         <p:spPr>
           <a:xfrm>
-            <a:off x="8439912" y="1243584"/>
-            <a:ext cx="3364992" cy="5010912"/>
-          </a:xfrm>
-          <a:prstGeom prst="roundRect">
-            <a:avLst>
-              <a:gd name="adj" fmla="val 2717"/>
-            </a:avLst>
+            <a:off x="8439912" y="1207008"/>
+            <a:ext cx="3364992" cy="5029200"/>
+          </a:xfrm>
+          <a:prstGeom prst="rect">
+            <a:avLst/>
           </a:prstGeom>
           <a:solidFill>
             <a:srgbClr val="FFFFFF"/>
           </a:solidFill>
           <a:ln w="12700">
             <a:solidFill>
-              <a:srgbClr val="DCE8E8"/>
+              <a:srgbClr val="E4E4E7"/>
             </a:solidFill>
             <a:prstDash val="solid"/>
           </a:ln>
@@ -3205,8 +3189,8 @@
         </p:nvSpPr>
         <p:spPr>
           <a:xfrm>
-            <a:off x="8686800" y="1536192"/>
-            <a:ext cx="2834640" cy="320040"/>
+            <a:off x="8686800" y="1545336"/>
+            <a:ext cx="2834640" cy="210312"/>
           </a:xfrm>
           <a:prstGeom prst="rect">
             <a:avLst/>
@@ -3222,14 +3206,14 @@
               <a:buNone/>
             </a:pPr>
             <a:r>
-              <a:rPr lang="en-US" sz="1500" b="1" dirty="0">
-                <a:solidFill>
-                  <a:srgbClr val="14353E"/>
-                </a:solidFill>
-              </a:rPr>
-              <a:t>What this shows</a:t>
-            </a:r>
-            <a:endParaRPr lang="en-US" sz="1500" dirty="0"/>
+              <a:rPr lang="en-US" sz="900" b="1" spc="160" kern="0" dirty="0">
+                <a:solidFill>
+                  <a:srgbClr val="4338CA"/>
+                </a:solidFill>
+              </a:rPr>
+              <a:t>IN THIS VIEW</a:t>
+            </a:r>
+            <a:endParaRPr lang="en-US" sz="900" dirty="0"/>
           </a:p>
         </p:txBody>
       </p:sp>
@@ -3241,18 +3225,18 @@
         </p:nvSpPr>
         <p:spPr>
           <a:xfrm>
-            <a:off x="8695944" y="2112264"/>
-            <a:ext cx="91440" cy="91440"/>
-          </a:xfrm>
-          <a:prstGeom prst="ellipse">
-            <a:avLst/>
-          </a:prstGeom>
-          <a:solidFill>
-            <a:srgbClr val="087E73"/>
+            <a:off x="8695944" y="2066544"/>
+            <a:ext cx="73152" cy="73152"/>
+          </a:xfrm>
+          <a:prstGeom prst="rect">
+            <a:avLst/>
+          </a:prstGeom>
+          <a:solidFill>
+            <a:srgbClr val="4338CA"/>
           </a:solidFill>
           <a:ln w="12700">
             <a:solidFill>
-              <a:srgbClr val="087E73"/>
+              <a:srgbClr val="4338CA"/>
             </a:solidFill>
             <a:prstDash val="solid"/>
           </a:ln>
@@ -3266,8 +3250,8 @@
         </p:nvSpPr>
         <p:spPr>
           <a:xfrm>
-            <a:off x="8915400" y="2057400"/>
-            <a:ext cx="2606040" cy="758952"/>
+            <a:off x="8915400" y="2011680"/>
+            <a:ext cx="2606040" cy="850392"/>
           </a:xfrm>
           <a:prstGeom prst="rect">
             <a:avLst/>
@@ -3285,14 +3269,14 @@
               <a:buNone/>
             </a:pPr>
             <a:r>
-              <a:rPr lang="en-US" sz="1200" dirty="0">
-                <a:solidFill>
-                  <a:srgbClr val="14353E"/>
-                </a:solidFill>
-              </a:rPr>
-              <a:t>Members see their own tasks and tasks shared with their groups.</a:t>
-            </a:r>
-            <a:endParaRPr lang="en-US" sz="1200" dirty="0"/>
+              <a:rPr lang="en-US" sz="1250" dirty="0">
+                <a:solidFill>
+                  <a:srgbClr val="0A0A0A"/>
+                </a:solidFill>
+              </a:rPr>
+              <a:t>Members see owned tasks and work shared through groups.</a:t>
+            </a:r>
+            <a:endParaRPr lang="en-US" sz="1250" dirty="0"/>
           </a:p>
         </p:txBody>
       </p:sp>
@@ -3304,18 +3288,18 @@
         </p:nvSpPr>
         <p:spPr>
           <a:xfrm>
-            <a:off x="8695944" y="3118104"/>
-            <a:ext cx="91440" cy="91440"/>
-          </a:xfrm>
-          <a:prstGeom prst="ellipse">
-            <a:avLst/>
-          </a:prstGeom>
-          <a:solidFill>
-            <a:srgbClr val="087E73"/>
+            <a:off x="8695944" y="3300984"/>
+            <a:ext cx="73152" cy="73152"/>
+          </a:xfrm>
+          <a:prstGeom prst="rect">
+            <a:avLst/>
+          </a:prstGeom>
+          <a:solidFill>
+            <a:srgbClr val="4338CA"/>
           </a:solidFill>
           <a:ln w="12700">
             <a:solidFill>
-              <a:srgbClr val="087E73"/>
+              <a:srgbClr val="4338CA"/>
             </a:solidFill>
             <a:prstDash val="solid"/>
           </a:ln>
@@ -3329,8 +3313,8 @@
         </p:nvSpPr>
         <p:spPr>
           <a:xfrm>
-            <a:off x="8915400" y="3063240"/>
-            <a:ext cx="2606040" cy="758952"/>
+            <a:off x="8915400" y="3246120"/>
+            <a:ext cx="2606040" cy="850392"/>
           </a:xfrm>
           <a:prstGeom prst="rect">
             <a:avLst/>
@@ -3348,14 +3332,14 @@
               <a:buNone/>
             </a:pPr>
             <a:r>
-              <a:rPr lang="en-US" sz="1200" dirty="0">
-                <a:solidFill>
-                  <a:srgbClr val="14353E"/>
-                </a:solidFill>
-              </a:rPr>
-              <a:t>Private tasks stay hidden from other members.</a:t>
-            </a:r>
-            <a:endParaRPr lang="en-US" sz="1200" dirty="0"/>
+              <a:rPr lang="en-US" sz="1250" dirty="0">
+                <a:solidFill>
+                  <a:srgbClr val="0A0A0A"/>
+                </a:solidFill>
+              </a:rPr>
+              <a:t>They update progress and submit results.</a:t>
+            </a:r>
+            <a:endParaRPr lang="en-US" sz="1250" dirty="0"/>
           </a:p>
         </p:txBody>
       </p:sp>
@@ -3367,18 +3351,18 @@
         </p:nvSpPr>
         <p:spPr>
           <a:xfrm>
-            <a:off x="8695944" y="4123944"/>
-            <a:ext cx="91440" cy="91440"/>
-          </a:xfrm>
-          <a:prstGeom prst="ellipse">
-            <a:avLst/>
-          </a:prstGeom>
-          <a:solidFill>
-            <a:srgbClr val="087E73"/>
+            <a:off x="8695944" y="4535424"/>
+            <a:ext cx="73152" cy="73152"/>
+          </a:xfrm>
+          <a:prstGeom prst="rect">
+            <a:avLst/>
+          </a:prstGeom>
+          <a:solidFill>
+            <a:srgbClr val="4338CA"/>
           </a:solidFill>
           <a:ln w="12700">
             <a:solidFill>
-              <a:srgbClr val="087E73"/>
+              <a:srgbClr val="4338CA"/>
             </a:solidFill>
             <a:prstDash val="solid"/>
           </a:ln>
@@ -3392,8 +3376,8 @@
         </p:nvSpPr>
         <p:spPr>
           <a:xfrm>
-            <a:off x="8915400" y="4069080"/>
-            <a:ext cx="2606040" cy="758952"/>
+            <a:off x="8915400" y="4480560"/>
+            <a:ext cx="2606040" cy="850392"/>
           </a:xfrm>
           <a:prstGeom prst="rect">
             <a:avLst/>
@@ -3411,14 +3395,14 @@
               <a:buNone/>
             </a:pPr>
             <a:r>
-              <a:rPr lang="en-US" sz="1200" dirty="0">
-                <a:solidFill>
-                  <a:srgbClr val="14353E"/>
-                </a:solidFill>
-              </a:rPr>
-              <a:t>Owners update progress and submit work.</a:t>
-            </a:r>
-            <a:endParaRPr lang="en-US" sz="1200" dirty="0"/>
+              <a:rPr lang="en-US" sz="1250" dirty="0">
+                <a:solidFill>
+                  <a:srgbClr val="0A0A0A"/>
+                </a:solidFill>
+              </a:rPr>
+              <a:t>Private work stays outside other members’ views.</a:t>
+            </a:r>
+            <a:endParaRPr lang="en-US" sz="1250" dirty="0"/>
           </a:p>
         </p:txBody>
       </p:sp>
@@ -3430,7 +3414,7 @@
         </p:nvSpPr>
         <p:spPr>
           <a:xfrm>
-            <a:off x="457200" y="6547104"/>
+            <a:off x="411480" y="6519672"/>
             <a:ext cx="4114800" cy="182880"/>
           </a:xfrm>
           <a:prstGeom prst="rect">
@@ -3449,10 +3433,10 @@
             <a:r>
               <a:rPr lang="en-US" sz="800" b="1" spc="100" kern="0" dirty="0">
                 <a:solidFill>
-                  <a:srgbClr val="087E73"/>
-                </a:solidFill>
-              </a:rPr>
-              <a:t>FICTIONAL DATA · PILOT DEMO</a:t>
+                  <a:srgbClr val="52525B"/>
+                </a:solidFill>
+              </a:rPr>
+              <a:t>FICTIONAL DATA  /  OCT 2026</a:t>
             </a:r>
             <a:endParaRPr lang="en-US" sz="800" dirty="0"/>
           </a:p>
@@ -3466,8 +3450,8 @@
         </p:nvSpPr>
         <p:spPr>
           <a:xfrm>
-            <a:off x="11155680" y="6510528"/>
-            <a:ext cx="548640" cy="228600"/>
+            <a:off x="11018520" y="6510528"/>
+            <a:ext cx="685800" cy="228600"/>
           </a:xfrm>
           <a:prstGeom prst="rect">
             <a:avLst/>
@@ -3485,10 +3469,10 @@
             <a:r>
               <a:rPr lang="en-US" sz="900" dirty="0">
                 <a:solidFill>
-                  <a:srgbClr val="607984"/>
-                </a:solidFill>
-              </a:rPr>
-              <a:t>04</a:t>
+                  <a:srgbClr val="52525B"/>
+                </a:solidFill>
+              </a:rPr>
+              <a:t>04 / 08</a:t>
             </a:r>
             <a:endParaRPr lang="en-US" sz="900" dirty="0"/>
           </a:p>
@@ -3508,7 +3492,7 @@
     <p:bg>
       <p:bgPr>
         <a:solidFill>
-          <a:srgbClr val="F6F9F9"/>
+          <a:srgbClr val="FAFAFA"/>
         </a:solidFill>
       </p:bgPr>
     </p:bg>
@@ -3535,17 +3519,17 @@
         <p:spPr>
           <a:xfrm>
             <a:off x="0" y="0"/>
-            <a:ext cx="12191695" cy="146304"/>
-          </a:xfrm>
-          <a:prstGeom prst="rect">
-            <a:avLst/>
-          </a:prstGeom>
-          <a:solidFill>
-            <a:srgbClr val="087E73"/>
+            <a:ext cx="109728" cy="6858000"/>
+          </a:xfrm>
+          <a:prstGeom prst="rect">
+            <a:avLst/>
+          </a:prstGeom>
+          <a:solidFill>
+            <a:srgbClr val="4338CA"/>
           </a:solidFill>
           <a:ln w="12700">
             <a:solidFill>
-              <a:srgbClr val="087E73"/>
+              <a:srgbClr val="4338CA"/>
             </a:solidFill>
             <a:prstDash val="solid"/>
           </a:ln>
@@ -3559,8 +3543,8 @@
         </p:nvSpPr>
         <p:spPr>
           <a:xfrm>
-            <a:off x="438912" y="310896"/>
-            <a:ext cx="11064240" cy="384048"/>
+            <a:off x="411480" y="274320"/>
+            <a:ext cx="9144000" cy="182880"/>
           </a:xfrm>
           <a:prstGeom prst="rect">
             <a:avLst/>
@@ -3576,53 +3560,53 @@
               <a:buNone/>
             </a:pPr>
             <a:r>
-              <a:rPr lang="en-US" sz="2500" b="1" dirty="0">
-                <a:solidFill>
-                  <a:srgbClr val="14353E"/>
+              <a:rPr lang="en-US" sz="800" b="1" spc="180" kern="0" dirty="0">
+                <a:solidFill>
+                  <a:srgbClr val="4338CA"/>
+                </a:solidFill>
+              </a:rPr>
+              <a:t>TASK DETAIL</a:t>
+            </a:r>
+            <a:endParaRPr lang="en-US" sz="800" dirty="0"/>
+          </a:p>
+        </p:txBody>
+      </p:sp>
+      <p:sp>
+        <p:nvSpPr>
+          <p:cNvPr id="4" name="Text 2"/>
+          <p:cNvSpPr/>
+          <p:nvPr/>
+        </p:nvSpPr>
+        <p:spPr>
+          <a:xfrm>
+            <a:off x="411480" y="530352"/>
+            <a:ext cx="11064240" cy="457200"/>
+          </a:xfrm>
+          <a:prstGeom prst="rect">
+            <a:avLst/>
+          </a:prstGeom>
+          <a:noFill/>
+          <a:ln/>
+        </p:spPr>
+        <p:txBody>
+          <a:bodyPr wrap="square" lIns="0" tIns="0" rIns="0" bIns="0" rtlCol="0" anchor="ctr"/>
+          <a:lstStyle/>
+          <a:p>
+            <a:pPr indent="0" marL="0">
+              <a:buNone/>
+            </a:pPr>
+            <a:r>
+              <a:rPr lang="en-US" sz="2800" b="1" dirty="0">
+                <a:solidFill>
+                  <a:srgbClr val="0A0A0A"/>
                 </a:solidFill>
                 <a:latin typeface="Aptos Display" pitchFamily="34" charset="0"/>
                 <a:ea typeface="Aptos Display" pitchFamily="34" charset="-122"/>
                 <a:cs typeface="Aptos Display" pitchFamily="34" charset="-120"/>
               </a:rPr>
-              <a:t>Results, review, and history</a:t>
-            </a:r>
-            <a:endParaRPr lang="en-US" sz="2500" dirty="0"/>
-          </a:p>
-        </p:txBody>
-      </p:sp>
-      <p:sp>
-        <p:nvSpPr>
-          <p:cNvPr id="4" name="Text 2"/>
-          <p:cNvSpPr/>
-          <p:nvPr/>
-        </p:nvSpPr>
-        <p:spPr>
-          <a:xfrm>
-            <a:off x="457200" y="758952"/>
-            <a:ext cx="10972800" cy="292608"/>
-          </a:xfrm>
-          <a:prstGeom prst="rect">
-            <a:avLst/>
-          </a:prstGeom>
-          <a:noFill/>
-          <a:ln/>
-        </p:spPr>
-        <p:txBody>
-          <a:bodyPr wrap="square" lIns="0" tIns="0" rIns="0" bIns="0" rtlCol="0" anchor="ctr"/>
-          <a:lstStyle/>
-          <a:p>
-            <a:pPr indent="0" marL="0">
-              <a:buNone/>
-            </a:pPr>
-            <a:r>
-              <a:rPr lang="en-US" sz="1050" dirty="0">
-                <a:solidFill>
-                  <a:srgbClr val="607984"/>
-                </a:solidFill>
-              </a:rPr>
-              <a:t>Task detail</a:t>
-            </a:r>
-            <a:endParaRPr lang="en-US" sz="1050" dirty="0"/>
+              <a:t>Results and evidence</a:t>
+            </a:r>
+            <a:endParaRPr lang="en-US" sz="2800" dirty="0"/>
           </a:p>
         </p:txBody>
       </p:sp>
@@ -3634,20 +3618,18 @@
         </p:nvSpPr>
         <p:spPr>
           <a:xfrm>
-            <a:off x="365760" y="1243584"/>
-            <a:ext cx="7818120" cy="5010912"/>
-          </a:xfrm>
-          <a:prstGeom prst="roundRect">
-            <a:avLst>
-              <a:gd name="adj" fmla="val 1825"/>
-            </a:avLst>
+            <a:off x="365760" y="1207008"/>
+            <a:ext cx="7818120" cy="5029200"/>
+          </a:xfrm>
+          <a:prstGeom prst="rect">
+            <a:avLst/>
           </a:prstGeom>
           <a:solidFill>
             <a:srgbClr val="FFFFFF"/>
           </a:solidFill>
           <a:ln w="12700">
             <a:solidFill>
-              <a:srgbClr val="DCE8E8"/>
+              <a:srgbClr val="E4E4E7"/>
             </a:solidFill>
             <a:prstDash val="solid"/>
           </a:ln>
@@ -3669,8 +3651,8 @@
         </p:blipFill>
         <p:spPr>
           <a:xfrm>
-            <a:off x="411480" y="1289304"/>
-            <a:ext cx="7726680" cy="4919472"/>
+            <a:off x="402336" y="1243584"/>
+            <a:ext cx="7744968" cy="4956048"/>
           </a:xfrm>
           <a:prstGeom prst="rect">
             <a:avLst/>
@@ -3685,20 +3667,18 @@
         </p:nvSpPr>
         <p:spPr>
           <a:xfrm>
-            <a:off x="8439912" y="1243584"/>
-            <a:ext cx="3364992" cy="5010912"/>
-          </a:xfrm>
-          <a:prstGeom prst="roundRect">
-            <a:avLst>
-              <a:gd name="adj" fmla="val 2717"/>
-            </a:avLst>
+            <a:off x="8439912" y="1207008"/>
+            <a:ext cx="3364992" cy="5029200"/>
+          </a:xfrm>
+          <a:prstGeom prst="rect">
+            <a:avLst/>
           </a:prstGeom>
           <a:solidFill>
             <a:srgbClr val="FFFFFF"/>
           </a:solidFill>
           <a:ln w="12700">
             <a:solidFill>
-              <a:srgbClr val="DCE8E8"/>
+              <a:srgbClr val="E4E4E7"/>
             </a:solidFill>
             <a:prstDash val="solid"/>
           </a:ln>
@@ -3712,8 +3692,8 @@
         </p:nvSpPr>
         <p:spPr>
           <a:xfrm>
-            <a:off x="8686800" y="1536192"/>
-            <a:ext cx="2834640" cy="320040"/>
+            <a:off x="8686800" y="1545336"/>
+            <a:ext cx="2834640" cy="210312"/>
           </a:xfrm>
           <a:prstGeom prst="rect">
             <a:avLst/>
@@ -3729,14 +3709,14 @@
               <a:buNone/>
             </a:pPr>
             <a:r>
-              <a:rPr lang="en-US" sz="1500" b="1" dirty="0">
-                <a:solidFill>
-                  <a:srgbClr val="14353E"/>
-                </a:solidFill>
-              </a:rPr>
-              <a:t>What this shows</a:t>
-            </a:r>
-            <a:endParaRPr lang="en-US" sz="1500" dirty="0"/>
+              <a:rPr lang="en-US" sz="900" b="1" spc="160" kern="0" dirty="0">
+                <a:solidFill>
+                  <a:srgbClr val="4338CA"/>
+                </a:solidFill>
+              </a:rPr>
+              <a:t>IN THIS VIEW</a:t>
+            </a:r>
+            <a:endParaRPr lang="en-US" sz="900" dirty="0"/>
           </a:p>
         </p:txBody>
       </p:sp>
@@ -3748,18 +3728,18 @@
         </p:nvSpPr>
         <p:spPr>
           <a:xfrm>
-            <a:off x="8695944" y="2112264"/>
-            <a:ext cx="91440" cy="91440"/>
-          </a:xfrm>
-          <a:prstGeom prst="ellipse">
-            <a:avLst/>
-          </a:prstGeom>
-          <a:solidFill>
-            <a:srgbClr val="087E73"/>
+            <a:off x="8695944" y="2066544"/>
+            <a:ext cx="73152" cy="73152"/>
+          </a:xfrm>
+          <a:prstGeom prst="rect">
+            <a:avLst/>
+          </a:prstGeom>
+          <a:solidFill>
+            <a:srgbClr val="4338CA"/>
           </a:solidFill>
           <a:ln w="12700">
             <a:solidFill>
-              <a:srgbClr val="087E73"/>
+              <a:srgbClr val="4338CA"/>
             </a:solidFill>
             <a:prstDash val="solid"/>
           </a:ln>
@@ -3773,8 +3753,8 @@
         </p:nvSpPr>
         <p:spPr>
           <a:xfrm>
-            <a:off x="8915400" y="2057400"/>
-            <a:ext cx="2606040" cy="758952"/>
+            <a:off x="8915400" y="2011680"/>
+            <a:ext cx="2606040" cy="850392"/>
           </a:xfrm>
           <a:prstGeom prst="rect">
             <a:avLst/>
@@ -3792,14 +3772,14 @@
               <a:buNone/>
             </a:pPr>
             <a:r>
-              <a:rPr lang="en-US" sz="1200" dirty="0">
-                <a:solidFill>
-                  <a:srgbClr val="14353E"/>
-                </a:solidFill>
-              </a:rPr>
-              <a:t>The PM can return or accept a submitted result.</a:t>
-            </a:r>
-            <a:endParaRPr lang="en-US" sz="1200" dirty="0"/>
+              <a:rPr lang="en-US" sz="1250" dirty="0">
+                <a:solidFill>
+                  <a:srgbClr val="0A0A0A"/>
+                </a:solidFill>
+              </a:rPr>
+              <a:t>Submitted results can be returned, revised, and accepted.</a:t>
+            </a:r>
+            <a:endParaRPr lang="en-US" sz="1250" dirty="0"/>
           </a:p>
         </p:txBody>
       </p:sp>
@@ -3811,18 +3791,18 @@
         </p:nvSpPr>
         <p:spPr>
           <a:xfrm>
-            <a:off x="8695944" y="3118104"/>
-            <a:ext cx="91440" cy="91440"/>
-          </a:xfrm>
-          <a:prstGeom prst="ellipse">
-            <a:avLst/>
-          </a:prstGeom>
-          <a:solidFill>
-            <a:srgbClr val="087E73"/>
+            <a:off x="8695944" y="3300984"/>
+            <a:ext cx="73152" cy="73152"/>
+          </a:xfrm>
+          <a:prstGeom prst="rect">
+            <a:avLst/>
+          </a:prstGeom>
+          <a:solidFill>
+            <a:srgbClr val="4338CA"/>
           </a:solidFill>
           <a:ln w="12700">
             <a:solidFill>
-              <a:srgbClr val="087E73"/>
+              <a:srgbClr val="4338CA"/>
             </a:solidFill>
             <a:prstDash val="solid"/>
           </a:ln>
@@ -3836,8 +3816,8 @@
         </p:nvSpPr>
         <p:spPr>
           <a:xfrm>
-            <a:off x="8915400" y="3063240"/>
-            <a:ext cx="2606040" cy="758952"/>
+            <a:off x="8915400" y="3246120"/>
+            <a:ext cx="2606040" cy="850392"/>
           </a:xfrm>
           <a:prstGeom prst="rect">
             <a:avLst/>
@@ -3855,14 +3835,14 @@
               <a:buNone/>
             </a:pPr>
             <a:r>
-              <a:rPr lang="en-US" sz="1200" dirty="0">
-                <a:solidFill>
-                  <a:srgbClr val="14353E"/>
-                </a:solidFill>
-              </a:rPr>
-              <a:t>Earlier result and attachment versions remain available.</a:t>
-            </a:r>
-            <a:endParaRPr lang="en-US" sz="1200" dirty="0"/>
+              <a:rPr lang="en-US" sz="1250" dirty="0">
+                <a:solidFill>
+                  <a:srgbClr val="0A0A0A"/>
+                </a:solidFill>
+              </a:rPr>
+              <a:t>Document versions remain available to authorized users.</a:t>
+            </a:r>
+            <a:endParaRPr lang="en-US" sz="1250" dirty="0"/>
           </a:p>
         </p:txBody>
       </p:sp>
@@ -3874,18 +3854,18 @@
         </p:nvSpPr>
         <p:spPr>
           <a:xfrm>
-            <a:off x="8695944" y="4123944"/>
-            <a:ext cx="91440" cy="91440"/>
-          </a:xfrm>
-          <a:prstGeom prst="ellipse">
-            <a:avLst/>
-          </a:prstGeom>
-          <a:solidFill>
-            <a:srgbClr val="087E73"/>
+            <a:off x="8695944" y="4535424"/>
+            <a:ext cx="73152" cy="73152"/>
+          </a:xfrm>
+          <a:prstGeom prst="rect">
+            <a:avLst/>
+          </a:prstGeom>
+          <a:solidFill>
+            <a:srgbClr val="4338CA"/>
           </a:solidFill>
           <a:ln w="12700">
             <a:solidFill>
-              <a:srgbClr val="087E73"/>
+              <a:srgbClr val="4338CA"/>
             </a:solidFill>
             <a:prstDash val="solid"/>
           </a:ln>
@@ -3899,8 +3879,8 @@
         </p:nvSpPr>
         <p:spPr>
           <a:xfrm>
-            <a:off x="8915400" y="4069080"/>
-            <a:ext cx="2606040" cy="758952"/>
+            <a:off x="8915400" y="4480560"/>
+            <a:ext cx="2606040" cy="850392"/>
           </a:xfrm>
           <a:prstGeom prst="rect">
             <a:avLst/>
@@ -3918,14 +3898,14 @@
               <a:buNone/>
             </a:pPr>
             <a:r>
-              <a:rPr lang="en-US" sz="1200" dirty="0">
-                <a:solidFill>
-                  <a:srgbClr val="14353E"/>
-                </a:solidFill>
-              </a:rPr>
-              <a:t>The timeline records task events and supports CSV export.</a:t>
-            </a:r>
-            <a:endParaRPr lang="en-US" sz="1200" dirty="0"/>
+              <a:rPr lang="en-US" sz="1250" dirty="0">
+                <a:solidFill>
+                  <a:srgbClr val="0A0A0A"/>
+                </a:solidFill>
+              </a:rPr>
+              <a:t>Task history records the sequence of changes.</a:t>
+            </a:r>
+            <a:endParaRPr lang="en-US" sz="1250" dirty="0"/>
           </a:p>
         </p:txBody>
       </p:sp>
@@ -3937,7 +3917,7 @@
         </p:nvSpPr>
         <p:spPr>
           <a:xfrm>
-            <a:off x="457200" y="6547104"/>
+            <a:off x="411480" y="6519672"/>
             <a:ext cx="4114800" cy="182880"/>
           </a:xfrm>
           <a:prstGeom prst="rect">
@@ -3956,10 +3936,10 @@
             <a:r>
               <a:rPr lang="en-US" sz="800" b="1" spc="100" kern="0" dirty="0">
                 <a:solidFill>
-                  <a:srgbClr val="087E73"/>
-                </a:solidFill>
-              </a:rPr>
-              <a:t>FICTIONAL DATA · PILOT DEMO</a:t>
+                  <a:srgbClr val="52525B"/>
+                </a:solidFill>
+              </a:rPr>
+              <a:t>FICTIONAL DATA  /  OCT 2026</a:t>
             </a:r>
             <a:endParaRPr lang="en-US" sz="800" dirty="0"/>
           </a:p>
@@ -3973,8 +3953,8 @@
         </p:nvSpPr>
         <p:spPr>
           <a:xfrm>
-            <a:off x="11155680" y="6510528"/>
-            <a:ext cx="548640" cy="228600"/>
+            <a:off x="11018520" y="6510528"/>
+            <a:ext cx="685800" cy="228600"/>
           </a:xfrm>
           <a:prstGeom prst="rect">
             <a:avLst/>
@@ -3992,10 +3972,10 @@
             <a:r>
               <a:rPr lang="en-US" sz="900" dirty="0">
                 <a:solidFill>
-                  <a:srgbClr val="607984"/>
-                </a:solidFill>
-              </a:rPr>
-              <a:t>05</a:t>
+                  <a:srgbClr val="52525B"/>
+                </a:solidFill>
+              </a:rPr>
+              <a:t>05 / 08</a:t>
             </a:r>
             <a:endParaRPr lang="en-US" sz="900" dirty="0"/>
           </a:p>
@@ -4015,7 +3995,7 @@
     <p:bg>
       <p:bgPr>
         <a:solidFill>
-          <a:srgbClr val="F6F9F9"/>
+          <a:srgbClr val="FAFAFA"/>
         </a:solidFill>
       </p:bgPr>
     </p:bg>
@@ -4042,17 +4022,17 @@
         <p:spPr>
           <a:xfrm>
             <a:off x="0" y="0"/>
-            <a:ext cx="12191695" cy="146304"/>
-          </a:xfrm>
-          <a:prstGeom prst="rect">
-            <a:avLst/>
-          </a:prstGeom>
-          <a:solidFill>
-            <a:srgbClr val="087E73"/>
+            <a:ext cx="109728" cy="6858000"/>
+          </a:xfrm>
+          <a:prstGeom prst="rect">
+            <a:avLst/>
+          </a:prstGeom>
+          <a:solidFill>
+            <a:srgbClr val="4338CA"/>
           </a:solidFill>
           <a:ln w="12700">
             <a:solidFill>
-              <a:srgbClr val="087E73"/>
+              <a:srgbClr val="4338CA"/>
             </a:solidFill>
             <a:prstDash val="solid"/>
           </a:ln>
@@ -4066,8 +4046,8 @@
         </p:nvSpPr>
         <p:spPr>
           <a:xfrm>
-            <a:off x="438912" y="310896"/>
-            <a:ext cx="11064240" cy="384048"/>
+            <a:off x="411480" y="274320"/>
+            <a:ext cx="9144000" cy="182880"/>
           </a:xfrm>
           <a:prstGeom prst="rect">
             <a:avLst/>
@@ -4083,53 +4063,53 @@
               <a:buNone/>
             </a:pPr>
             <a:r>
-              <a:rPr lang="en-US" sz="2500" b="1" dirty="0">
-                <a:solidFill>
-                  <a:srgbClr val="14353E"/>
+              <a:rPr lang="en-US" sz="800" b="1" spc="180" kern="0" dirty="0">
+                <a:solidFill>
+                  <a:srgbClr val="4338CA"/>
+                </a:solidFill>
+              </a:rPr>
+              <a:t>PROJECT MANAGER</a:t>
+            </a:r>
+            <a:endParaRPr lang="en-US" sz="800" dirty="0"/>
+          </a:p>
+        </p:txBody>
+      </p:sp>
+      <p:sp>
+        <p:nvSpPr>
+          <p:cNvPr id="4" name="Text 2"/>
+          <p:cNvSpPr/>
+          <p:nvPr/>
+        </p:nvSpPr>
+        <p:spPr>
+          <a:xfrm>
+            <a:off x="411480" y="530352"/>
+            <a:ext cx="11064240" cy="457200"/>
+          </a:xfrm>
+          <a:prstGeom prst="rect">
+            <a:avLst/>
+          </a:prstGeom>
+          <a:noFill/>
+          <a:ln/>
+        </p:spPr>
+        <p:txBody>
+          <a:bodyPr wrap="square" lIns="0" tIns="0" rIns="0" bIns="0" rtlCol="0" anchor="ctr"/>
+          <a:lstStyle/>
+          <a:p>
+            <a:pPr indent="0" marL="0">
+              <a:buNone/>
+            </a:pPr>
+            <a:r>
+              <a:rPr lang="en-US" sz="2800" b="1" dirty="0">
+                <a:solidFill>
+                  <a:srgbClr val="0A0A0A"/>
                 </a:solidFill>
                 <a:latin typeface="Aptos Display" pitchFamily="34" charset="0"/>
                 <a:ea typeface="Aptos Display" pitchFamily="34" charset="-122"/>
                 <a:cs typeface="Aptos Display" pitchFamily="34" charset="-120"/>
               </a:rPr>
-              <a:t>Approvals awaiting action</a:t>
-            </a:r>
-            <a:endParaRPr lang="en-US" sz="2500" dirty="0"/>
-          </a:p>
-        </p:txBody>
-      </p:sp>
-      <p:sp>
-        <p:nvSpPr>
-          <p:cNvPr id="4" name="Text 2"/>
-          <p:cNvSpPr/>
-          <p:nvPr/>
-        </p:nvSpPr>
-        <p:spPr>
-          <a:xfrm>
-            <a:off x="457200" y="758952"/>
-            <a:ext cx="10972800" cy="292608"/>
-          </a:xfrm>
-          <a:prstGeom prst="rect">
-            <a:avLst/>
-          </a:prstGeom>
-          <a:noFill/>
-          <a:ln/>
-        </p:spPr>
-        <p:txBody>
-          <a:bodyPr wrap="square" lIns="0" tIns="0" rIns="0" bIns="0" rtlCol="0" anchor="ctr"/>
-          <a:lstStyle/>
-          <a:p>
-            <a:pPr indent="0" marL="0">
-              <a:buNone/>
-            </a:pPr>
-            <a:r>
-              <a:rPr lang="en-US" sz="1050" dirty="0">
-                <a:solidFill>
-                  <a:srgbClr val="607984"/>
-                </a:solidFill>
-              </a:rPr>
-              <a:t>PM and reviewer queues</a:t>
-            </a:r>
-            <a:endParaRPr lang="en-US" sz="1050" dirty="0"/>
+              <a:t>Pending decisions</a:t>
+            </a:r>
+            <a:endParaRPr lang="en-US" sz="2800" dirty="0"/>
           </a:p>
         </p:txBody>
       </p:sp>
@@ -4141,20 +4121,18 @@
         </p:nvSpPr>
         <p:spPr>
           <a:xfrm>
-            <a:off x="365760" y="1243584"/>
-            <a:ext cx="7818120" cy="5010912"/>
-          </a:xfrm>
-          <a:prstGeom prst="roundRect">
-            <a:avLst>
-              <a:gd name="adj" fmla="val 1825"/>
-            </a:avLst>
+            <a:off x="365760" y="1207008"/>
+            <a:ext cx="7818120" cy="5029200"/>
+          </a:xfrm>
+          <a:prstGeom prst="rect">
+            <a:avLst/>
           </a:prstGeom>
           <a:solidFill>
             <a:srgbClr val="FFFFFF"/>
           </a:solidFill>
           <a:ln w="12700">
             <a:solidFill>
-              <a:srgbClr val="DCE8E8"/>
+              <a:srgbClr val="E4E4E7"/>
             </a:solidFill>
             <a:prstDash val="solid"/>
           </a:ln>
@@ -4176,8 +4154,8 @@
         </p:blipFill>
         <p:spPr>
           <a:xfrm>
-            <a:off x="411480" y="1289304"/>
-            <a:ext cx="7726680" cy="4919472"/>
+            <a:off x="402336" y="1243584"/>
+            <a:ext cx="7744968" cy="4956048"/>
           </a:xfrm>
           <a:prstGeom prst="rect">
             <a:avLst/>
@@ -4192,20 +4170,18 @@
         </p:nvSpPr>
         <p:spPr>
           <a:xfrm>
-            <a:off x="8439912" y="1243584"/>
-            <a:ext cx="3364992" cy="5010912"/>
-          </a:xfrm>
-          <a:prstGeom prst="roundRect">
-            <a:avLst>
-              <a:gd name="adj" fmla="val 2717"/>
-            </a:avLst>
+            <a:off x="8439912" y="1207008"/>
+            <a:ext cx="3364992" cy="5029200"/>
+          </a:xfrm>
+          <a:prstGeom prst="rect">
+            <a:avLst/>
           </a:prstGeom>
           <a:solidFill>
             <a:srgbClr val="FFFFFF"/>
           </a:solidFill>
           <a:ln w="12700">
             <a:solidFill>
-              <a:srgbClr val="DCE8E8"/>
+              <a:srgbClr val="E4E4E7"/>
             </a:solidFill>
             <a:prstDash val="solid"/>
           </a:ln>
@@ -4219,8 +4195,8 @@
         </p:nvSpPr>
         <p:spPr>
           <a:xfrm>
-            <a:off x="8686800" y="1536192"/>
-            <a:ext cx="2834640" cy="320040"/>
+            <a:off x="8686800" y="1545336"/>
+            <a:ext cx="2834640" cy="210312"/>
           </a:xfrm>
           <a:prstGeom prst="rect">
             <a:avLst/>
@@ -4236,14 +4212,14 @@
               <a:buNone/>
             </a:pPr>
             <a:r>
-              <a:rPr lang="en-US" sz="1500" b="1" dirty="0">
-                <a:solidFill>
-                  <a:srgbClr val="14353E"/>
-                </a:solidFill>
-              </a:rPr>
-              <a:t>What this shows</a:t>
-            </a:r>
-            <a:endParaRPr lang="en-US" sz="1500" dirty="0"/>
+              <a:rPr lang="en-US" sz="900" b="1" spc="160" kern="0" dirty="0">
+                <a:solidFill>
+                  <a:srgbClr val="4338CA"/>
+                </a:solidFill>
+              </a:rPr>
+              <a:t>IN THIS VIEW</a:t>
+            </a:r>
+            <a:endParaRPr lang="en-US" sz="900" dirty="0"/>
           </a:p>
         </p:txBody>
       </p:sp>
@@ -4255,18 +4231,18 @@
         </p:nvSpPr>
         <p:spPr>
           <a:xfrm>
-            <a:off x="8695944" y="2112264"/>
-            <a:ext cx="91440" cy="91440"/>
-          </a:xfrm>
-          <a:prstGeom prst="ellipse">
-            <a:avLst/>
-          </a:prstGeom>
-          <a:solidFill>
-            <a:srgbClr val="087E73"/>
+            <a:off x="8695944" y="2066544"/>
+            <a:ext cx="73152" cy="73152"/>
+          </a:xfrm>
+          <a:prstGeom prst="rect">
+            <a:avLst/>
+          </a:prstGeom>
+          <a:solidFill>
+            <a:srgbClr val="4338CA"/>
           </a:solidFill>
           <a:ln w="12700">
             <a:solidFill>
-              <a:srgbClr val="087E73"/>
+              <a:srgbClr val="4338CA"/>
             </a:solidFill>
             <a:prstDash val="solid"/>
           </a:ln>
@@ -4280,8 +4256,8 @@
         </p:nvSpPr>
         <p:spPr>
           <a:xfrm>
-            <a:off x="8915400" y="2057400"/>
-            <a:ext cx="2606040" cy="758952"/>
+            <a:off x="8915400" y="2011680"/>
+            <a:ext cx="2606040" cy="850392"/>
           </a:xfrm>
           <a:prstGeom prst="rect">
             <a:avLst/>
@@ -4299,14 +4275,14 @@
               <a:buNone/>
             </a:pPr>
             <a:r>
-              <a:rPr lang="en-US" sz="1200" dirty="0">
-                <a:solidFill>
-                  <a:srgbClr val="14353E"/>
-                </a:solidFill>
-              </a:rPr>
-              <a:t>The PM sees result reviews and extension requests together.</a:t>
-            </a:r>
-            <a:endParaRPr lang="en-US" sz="1200" dirty="0"/>
+              <a:rPr lang="en-US" sz="1250" dirty="0">
+                <a:solidFill>
+                  <a:srgbClr val="0A0A0A"/>
+                </a:solidFill>
+              </a:rPr>
+              <a:t>Result reviews and due date requests appear in one queue.</a:t>
+            </a:r>
+            <a:endParaRPr lang="en-US" sz="1250" dirty="0"/>
           </a:p>
         </p:txBody>
       </p:sp>
@@ -4318,18 +4294,18 @@
         </p:nvSpPr>
         <p:spPr>
           <a:xfrm>
-            <a:off x="8695944" y="3118104"/>
-            <a:ext cx="91440" cy="91440"/>
-          </a:xfrm>
-          <a:prstGeom prst="ellipse">
-            <a:avLst/>
-          </a:prstGeom>
-          <a:solidFill>
-            <a:srgbClr val="087E73"/>
+            <a:off x="8695944" y="3300984"/>
+            <a:ext cx="73152" cy="73152"/>
+          </a:xfrm>
+          <a:prstGeom prst="rect">
+            <a:avLst/>
+          </a:prstGeom>
+          <a:solidFill>
+            <a:srgbClr val="4338CA"/>
           </a:solidFill>
           <a:ln w="12700">
             <a:solidFill>
-              <a:srgbClr val="087E73"/>
+              <a:srgbClr val="4338CA"/>
             </a:solidFill>
             <a:prstDash val="solid"/>
           </a:ln>
@@ -4343,8 +4319,8 @@
         </p:nvSpPr>
         <p:spPr>
           <a:xfrm>
-            <a:off x="8915400" y="3063240"/>
-            <a:ext cx="2606040" cy="758952"/>
+            <a:off x="8915400" y="3246120"/>
+            <a:ext cx="2606040" cy="850392"/>
           </a:xfrm>
           <a:prstGeom prst="rect">
             <a:avLst/>
@@ -4362,14 +4338,14 @@
               <a:buNone/>
             </a:pPr>
             <a:r>
-              <a:rPr lang="en-US" sz="1200" dirty="0">
-                <a:solidFill>
-                  <a:srgbClr val="14353E"/>
-                </a:solidFill>
-              </a:rPr>
-              <a:t>Reassignments use a separate reviewer approval step.</a:t>
-            </a:r>
-            <a:endParaRPr lang="en-US" sz="1200" dirty="0"/>
+              <a:rPr lang="en-US" sz="1250" dirty="0">
+                <a:solidFill>
+                  <a:srgbClr val="0A0A0A"/>
+                </a:solidFill>
+              </a:rPr>
+              <a:t>Approval or rejection updates the task and history.</a:t>
+            </a:r>
+            <a:endParaRPr lang="en-US" sz="1250" dirty="0"/>
           </a:p>
         </p:txBody>
       </p:sp>
@@ -4381,18 +4357,18 @@
         </p:nvSpPr>
         <p:spPr>
           <a:xfrm>
-            <a:off x="8695944" y="4123944"/>
-            <a:ext cx="91440" cy="91440"/>
-          </a:xfrm>
-          <a:prstGeom prst="ellipse">
-            <a:avLst/>
-          </a:prstGeom>
-          <a:solidFill>
-            <a:srgbClr val="087E73"/>
+            <a:off x="8695944" y="4535424"/>
+            <a:ext cx="73152" cy="73152"/>
+          </a:xfrm>
+          <a:prstGeom prst="rect">
+            <a:avLst/>
+          </a:prstGeom>
+          <a:solidFill>
+            <a:srgbClr val="4338CA"/>
           </a:solidFill>
           <a:ln w="12700">
             <a:solidFill>
-              <a:srgbClr val="087E73"/>
+              <a:srgbClr val="4338CA"/>
             </a:solidFill>
             <a:prstDash val="solid"/>
           </a:ln>
@@ -4406,8 +4382,8 @@
         </p:nvSpPr>
         <p:spPr>
           <a:xfrm>
-            <a:off x="8915400" y="4069080"/>
-            <a:ext cx="2606040" cy="758952"/>
+            <a:off x="8915400" y="4480560"/>
+            <a:ext cx="2606040" cy="850392"/>
           </a:xfrm>
           <a:prstGeom prst="rect">
             <a:avLst/>
@@ -4425,14 +4401,14 @@
               <a:buNone/>
             </a:pPr>
             <a:r>
-              <a:rPr lang="en-US" sz="1200" dirty="0">
-                <a:solidFill>
-                  <a:srgbClr val="14353E"/>
-                </a:solidFill>
-              </a:rPr>
-              <a:t>Decisions update task history and leave the queue.</a:t>
-            </a:r>
-            <a:endParaRPr lang="en-US" sz="1200" dirty="0"/>
+              <a:rPr lang="en-US" sz="1250" dirty="0">
+                <a:solidFill>
+                  <a:srgbClr val="0A0A0A"/>
+                </a:solidFill>
+              </a:rPr>
+              <a:t>Completed decisions leave the queue.</a:t>
+            </a:r>
+            <a:endParaRPr lang="en-US" sz="1250" dirty="0"/>
           </a:p>
         </p:txBody>
       </p:sp>
@@ -4444,7 +4420,7 @@
         </p:nvSpPr>
         <p:spPr>
           <a:xfrm>
-            <a:off x="457200" y="6547104"/>
+            <a:off x="411480" y="6519672"/>
             <a:ext cx="4114800" cy="182880"/>
           </a:xfrm>
           <a:prstGeom prst="rect">
@@ -4463,10 +4439,10 @@
             <a:r>
               <a:rPr lang="en-US" sz="800" b="1" spc="100" kern="0" dirty="0">
                 <a:solidFill>
-                  <a:srgbClr val="087E73"/>
-                </a:solidFill>
-              </a:rPr>
-              <a:t>FICTIONAL DATA · PILOT DEMO</a:t>
+                  <a:srgbClr val="52525B"/>
+                </a:solidFill>
+              </a:rPr>
+              <a:t>FICTIONAL DATA  /  OCT 2026</a:t>
             </a:r>
             <a:endParaRPr lang="en-US" sz="800" dirty="0"/>
           </a:p>
@@ -4480,8 +4456,8 @@
         </p:nvSpPr>
         <p:spPr>
           <a:xfrm>
-            <a:off x="11155680" y="6510528"/>
-            <a:ext cx="548640" cy="228600"/>
+            <a:off x="11018520" y="6510528"/>
+            <a:ext cx="685800" cy="228600"/>
           </a:xfrm>
           <a:prstGeom prst="rect">
             <a:avLst/>
@@ -4499,10 +4475,10 @@
             <a:r>
               <a:rPr lang="en-US" sz="900" dirty="0">
                 <a:solidFill>
-                  <a:srgbClr val="607984"/>
-                </a:solidFill>
-              </a:rPr>
-              <a:t>06</a:t>
+                  <a:srgbClr val="52525B"/>
+                </a:solidFill>
+              </a:rPr>
+              <a:t>06 / 08</a:t>
             </a:r>
             <a:endParaRPr lang="en-US" sz="900" dirty="0"/>
           </a:p>
@@ -4522,7 +4498,7 @@
     <p:bg>
       <p:bgPr>
         <a:solidFill>
-          <a:srgbClr val="F6F9F9"/>
+          <a:srgbClr val="FAFAFA"/>
         </a:solidFill>
       </p:bgPr>
     </p:bg>
@@ -4549,17 +4525,17 @@
         <p:spPr>
           <a:xfrm>
             <a:off x="0" y="0"/>
-            <a:ext cx="12191695" cy="146304"/>
-          </a:xfrm>
-          <a:prstGeom prst="rect">
-            <a:avLst/>
-          </a:prstGeom>
-          <a:solidFill>
-            <a:srgbClr val="087E73"/>
+            <a:ext cx="109728" cy="6858000"/>
+          </a:xfrm>
+          <a:prstGeom prst="rect">
+            <a:avLst/>
+          </a:prstGeom>
+          <a:solidFill>
+            <a:srgbClr val="4338CA"/>
           </a:solidFill>
           <a:ln w="12700">
             <a:solidFill>
-              <a:srgbClr val="087E73"/>
+              <a:srgbClr val="4338CA"/>
             </a:solidFill>
             <a:prstDash val="solid"/>
           </a:ln>
@@ -4573,8 +4549,8 @@
         </p:nvSpPr>
         <p:spPr>
           <a:xfrm>
-            <a:off x="438912" y="310896"/>
-            <a:ext cx="11064240" cy="384048"/>
+            <a:off x="411480" y="274320"/>
+            <a:ext cx="9144000" cy="182880"/>
           </a:xfrm>
           <a:prstGeom prst="rect">
             <a:avLst/>
@@ -4590,53 +4566,53 @@
               <a:buNone/>
             </a:pPr>
             <a:r>
-              <a:rPr lang="en-US" sz="2500" b="1" dirty="0">
-                <a:solidFill>
-                  <a:srgbClr val="14353E"/>
+              <a:rPr lang="en-US" sz="800" b="1" spc="180" kern="0" dirty="0">
+                <a:solidFill>
+                  <a:srgbClr val="4338CA"/>
+                </a:solidFill>
+              </a:rPr>
+              <a:t>REVIEWER</a:t>
+            </a:r>
+            <a:endParaRPr lang="en-US" sz="800" dirty="0"/>
+          </a:p>
+        </p:txBody>
+      </p:sp>
+      <p:sp>
+        <p:nvSpPr>
+          <p:cNvPr id="4" name="Text 2"/>
+          <p:cNvSpPr/>
+          <p:nvPr/>
+        </p:nvSpPr>
+        <p:spPr>
+          <a:xfrm>
+            <a:off x="411480" y="530352"/>
+            <a:ext cx="11064240" cy="457200"/>
+          </a:xfrm>
+          <a:prstGeom prst="rect">
+            <a:avLst/>
+          </a:prstGeom>
+          <a:noFill/>
+          <a:ln/>
+        </p:spPr>
+        <p:txBody>
+          <a:bodyPr wrap="square" lIns="0" tIns="0" rIns="0" bIns="0" rtlCol="0" anchor="ctr"/>
+          <a:lstStyle/>
+          <a:p>
+            <a:pPr indent="0" marL="0">
+              <a:buNone/>
+            </a:pPr>
+            <a:r>
+              <a:rPr lang="en-US" sz="2800" b="1" dirty="0">
+                <a:solidFill>
+                  <a:srgbClr val="0A0A0A"/>
                 </a:solidFill>
                 <a:latin typeface="Aptos Display" pitchFamily="34" charset="0"/>
                 <a:ea typeface="Aptos Display" pitchFamily="34" charset="-122"/>
                 <a:cs typeface="Aptos Display" pitchFamily="34" charset="-120"/>
               </a:rPr>
-              <a:t>Reviewer decision</a:t>
-            </a:r>
-            <a:endParaRPr lang="en-US" sz="2500" dirty="0"/>
-          </a:p>
-        </p:txBody>
-      </p:sp>
-      <p:sp>
-        <p:nvSpPr>
-          <p:cNvPr id="4" name="Text 2"/>
-          <p:cNvSpPr/>
-          <p:nvPr/>
-        </p:nvSpPr>
-        <p:spPr>
-          <a:xfrm>
-            <a:off x="457200" y="758952"/>
-            <a:ext cx="10972800" cy="292608"/>
-          </a:xfrm>
-          <a:prstGeom prst="rect">
-            <a:avLst/>
-          </a:prstGeom>
-          <a:noFill/>
-          <a:ln/>
-        </p:spPr>
-        <p:txBody>
-          <a:bodyPr wrap="square" lIns="0" tIns="0" rIns="0" bIns="0" rtlCol="0" anchor="ctr"/>
-          <a:lstStyle/>
-          <a:p>
-            <a:pPr indent="0" marL="0">
-              <a:buNone/>
-            </a:pPr>
-            <a:r>
-              <a:rPr lang="en-US" sz="1050" dirty="0">
-                <a:solidFill>
-                  <a:srgbClr val="607984"/>
-                </a:solidFill>
-              </a:rPr>
-              <a:t>Reviewer view</a:t>
-            </a:r>
-            <a:endParaRPr lang="en-US" sz="1050" dirty="0"/>
+              <a:t>Independent reviewer</a:t>
+            </a:r>
+            <a:endParaRPr lang="en-US" sz="2800" dirty="0"/>
           </a:p>
         </p:txBody>
       </p:sp>
@@ -4648,20 +4624,18 @@
         </p:nvSpPr>
         <p:spPr>
           <a:xfrm>
-            <a:off x="365760" y="1243584"/>
-            <a:ext cx="7818120" cy="5010912"/>
-          </a:xfrm>
-          <a:prstGeom prst="roundRect">
-            <a:avLst>
-              <a:gd name="adj" fmla="val 1825"/>
-            </a:avLst>
+            <a:off x="365760" y="1207008"/>
+            <a:ext cx="7818120" cy="5029200"/>
+          </a:xfrm>
+          <a:prstGeom prst="rect">
+            <a:avLst/>
           </a:prstGeom>
           <a:solidFill>
             <a:srgbClr val="FFFFFF"/>
           </a:solidFill>
           <a:ln w="12700">
             <a:solidFill>
-              <a:srgbClr val="DCE8E8"/>
+              <a:srgbClr val="E4E4E7"/>
             </a:solidFill>
             <a:prstDash val="solid"/>
           </a:ln>
@@ -4683,8 +4657,8 @@
         </p:blipFill>
         <p:spPr>
           <a:xfrm>
-            <a:off x="411480" y="1289304"/>
-            <a:ext cx="7726680" cy="4919472"/>
+            <a:off x="402336" y="1243584"/>
+            <a:ext cx="7744968" cy="4956048"/>
           </a:xfrm>
           <a:prstGeom prst="rect">
             <a:avLst/>
@@ -4699,20 +4673,18 @@
         </p:nvSpPr>
         <p:spPr>
           <a:xfrm>
-            <a:off x="8439912" y="1243584"/>
-            <a:ext cx="3364992" cy="5010912"/>
-          </a:xfrm>
-          <a:prstGeom prst="roundRect">
-            <a:avLst>
-              <a:gd name="adj" fmla="val 2717"/>
-            </a:avLst>
+            <a:off x="8439912" y="1207008"/>
+            <a:ext cx="3364992" cy="5029200"/>
+          </a:xfrm>
+          <a:prstGeom prst="rect">
+            <a:avLst/>
           </a:prstGeom>
           <a:solidFill>
             <a:srgbClr val="FFFFFF"/>
           </a:solidFill>
           <a:ln w="12700">
             <a:solidFill>
-              <a:srgbClr val="DCE8E8"/>
+              <a:srgbClr val="E4E4E7"/>
             </a:solidFill>
             <a:prstDash val="solid"/>
           </a:ln>
@@ -4726,8 +4698,8 @@
         </p:nvSpPr>
         <p:spPr>
           <a:xfrm>
-            <a:off x="8686800" y="1536192"/>
-            <a:ext cx="2834640" cy="320040"/>
+            <a:off x="8686800" y="1545336"/>
+            <a:ext cx="2834640" cy="210312"/>
           </a:xfrm>
           <a:prstGeom prst="rect">
             <a:avLst/>
@@ -4743,14 +4715,14 @@
               <a:buNone/>
             </a:pPr>
             <a:r>
-              <a:rPr lang="en-US" sz="1500" b="1" dirty="0">
-                <a:solidFill>
-                  <a:srgbClr val="14353E"/>
-                </a:solidFill>
-              </a:rPr>
-              <a:t>What this shows</a:t>
-            </a:r>
-            <a:endParaRPr lang="en-US" sz="1500" dirty="0"/>
+              <a:rPr lang="en-US" sz="900" b="1" spc="160" kern="0" dirty="0">
+                <a:solidFill>
+                  <a:srgbClr val="4338CA"/>
+                </a:solidFill>
+              </a:rPr>
+              <a:t>IN THIS VIEW</a:t>
+            </a:r>
+            <a:endParaRPr lang="en-US" sz="900" dirty="0"/>
           </a:p>
         </p:txBody>
       </p:sp>
@@ -4762,18 +4734,18 @@
         </p:nvSpPr>
         <p:spPr>
           <a:xfrm>
-            <a:off x="8695944" y="2112264"/>
-            <a:ext cx="91440" cy="91440"/>
-          </a:xfrm>
-          <a:prstGeom prst="ellipse">
-            <a:avLst/>
-          </a:prstGeom>
-          <a:solidFill>
-            <a:srgbClr val="087E73"/>
+            <a:off x="8695944" y="2066544"/>
+            <a:ext cx="73152" cy="73152"/>
+          </a:xfrm>
+          <a:prstGeom prst="rect">
+            <a:avLst/>
+          </a:prstGeom>
+          <a:solidFill>
+            <a:srgbClr val="4338CA"/>
           </a:solidFill>
           <a:ln w="12700">
             <a:solidFill>
-              <a:srgbClr val="087E73"/>
+              <a:srgbClr val="4338CA"/>
             </a:solidFill>
             <a:prstDash val="solid"/>
           </a:ln>
@@ -4787,8 +4759,8 @@
         </p:nvSpPr>
         <p:spPr>
           <a:xfrm>
-            <a:off x="8915400" y="2057400"/>
-            <a:ext cx="2606040" cy="758952"/>
+            <a:off x="8915400" y="2011680"/>
+            <a:ext cx="2606040" cy="850392"/>
           </a:xfrm>
           <a:prstGeom prst="rect">
             <a:avLst/>
@@ -4806,14 +4778,14 @@
               <a:buNone/>
             </a:pPr>
             <a:r>
-              <a:rPr lang="en-US" sz="1200" dirty="0">
-                <a:solidFill>
-                  <a:srgbClr val="14353E"/>
-                </a:solidFill>
-              </a:rPr>
-              <a:t>A live reassignment request appears for the reviewer.</a:t>
-            </a:r>
-            <a:endParaRPr lang="en-US" sz="1200" dirty="0"/>
+              <a:rPr lang="en-US" sz="1250" dirty="0">
+                <a:solidFill>
+                  <a:srgbClr val="0A0A0A"/>
+                </a:solidFill>
+              </a:rPr>
+              <a:t>A reassignment request is routed to the reviewer.</a:t>
+            </a:r>
+            <a:endParaRPr lang="en-US" sz="1250" dirty="0"/>
           </a:p>
         </p:txBody>
       </p:sp>
@@ -4825,18 +4797,18 @@
         </p:nvSpPr>
         <p:spPr>
           <a:xfrm>
-            <a:off x="8695944" y="3118104"/>
-            <a:ext cx="91440" cy="91440"/>
-          </a:xfrm>
-          <a:prstGeom prst="ellipse">
-            <a:avLst/>
-          </a:prstGeom>
-          <a:solidFill>
-            <a:srgbClr val="087E73"/>
+            <a:off x="8695944" y="3300984"/>
+            <a:ext cx="73152" cy="73152"/>
+          </a:xfrm>
+          <a:prstGeom prst="rect">
+            <a:avLst/>
+          </a:prstGeom>
+          <a:solidFill>
+            <a:srgbClr val="4338CA"/>
           </a:solidFill>
           <a:ln w="12700">
             <a:solidFill>
-              <a:srgbClr val="087E73"/>
+              <a:srgbClr val="4338CA"/>
             </a:solidFill>
             <a:prstDash val="solid"/>
           </a:ln>
@@ -4850,8 +4822,8 @@
         </p:nvSpPr>
         <p:spPr>
           <a:xfrm>
-            <a:off x="8915400" y="3063240"/>
-            <a:ext cx="2606040" cy="758952"/>
+            <a:off x="8915400" y="3246120"/>
+            <a:ext cx="2606040" cy="850392"/>
           </a:xfrm>
           <a:prstGeom prst="rect">
             <a:avLst/>
@@ -4869,14 +4841,14 @@
               <a:buNone/>
             </a:pPr>
             <a:r>
-              <a:rPr lang="en-US" sz="1200" dirty="0">
-                <a:solidFill>
-                  <a:srgbClr val="14353E"/>
-                </a:solidFill>
-              </a:rPr>
-              <a:t>Approval changes ownership; rejection keeps it unchanged.</a:t>
-            </a:r>
-            <a:endParaRPr lang="en-US" sz="1200" dirty="0"/>
+              <a:rPr lang="en-US" sz="1250" dirty="0">
+                <a:solidFill>
+                  <a:srgbClr val="0A0A0A"/>
+                </a:solidFill>
+              </a:rPr>
+              <a:t>Approval changes ownership; rejection retains it.</a:t>
+            </a:r>
+            <a:endParaRPr lang="en-US" sz="1250" dirty="0"/>
           </a:p>
         </p:txBody>
       </p:sp>
@@ -4888,18 +4860,18 @@
         </p:nvSpPr>
         <p:spPr>
           <a:xfrm>
-            <a:off x="8695944" y="4123944"/>
-            <a:ext cx="91440" cy="91440"/>
-          </a:xfrm>
-          <a:prstGeom prst="ellipse">
-            <a:avLst/>
-          </a:prstGeom>
-          <a:solidFill>
-            <a:srgbClr val="087E73"/>
+            <a:off x="8695944" y="4535424"/>
+            <a:ext cx="73152" cy="73152"/>
+          </a:xfrm>
+          <a:prstGeom prst="rect">
+            <a:avLst/>
+          </a:prstGeom>
+          <a:solidFill>
+            <a:srgbClr val="4338CA"/>
           </a:solidFill>
           <a:ln w="12700">
             <a:solidFill>
-              <a:srgbClr val="087E73"/>
+              <a:srgbClr val="4338CA"/>
             </a:solidFill>
             <a:prstDash val="solid"/>
           </a:ln>
@@ -4913,8 +4885,8 @@
         </p:nvSpPr>
         <p:spPr>
           <a:xfrm>
-            <a:off x="8915400" y="4069080"/>
-            <a:ext cx="2606040" cy="758952"/>
+            <a:off x="8915400" y="4480560"/>
+            <a:ext cx="2606040" cy="850392"/>
           </a:xfrm>
           <a:prstGeom prst="rect">
             <a:avLst/>
@@ -4932,14 +4904,14 @@
               <a:buNone/>
             </a:pPr>
             <a:r>
-              <a:rPr lang="en-US" sz="1200" dirty="0">
-                <a:solidFill>
-                  <a:srgbClr val="14353E"/>
-                </a:solidFill>
-              </a:rPr>
-              <a:t>Old and new owners receive a notification when SMTP is configured.</a:t>
-            </a:r>
-            <a:endParaRPr lang="en-US" sz="1200" dirty="0"/>
+              <a:rPr lang="en-US" sz="1250" dirty="0">
+                <a:solidFill>
+                  <a:srgbClr val="0A0A0A"/>
+                </a:solidFill>
+              </a:rPr>
+              <a:t>The action is recorded for audit and reporting.</a:t>
+            </a:r>
+            <a:endParaRPr lang="en-US" sz="1250" dirty="0"/>
           </a:p>
         </p:txBody>
       </p:sp>
@@ -4951,7 +4923,7 @@
         </p:nvSpPr>
         <p:spPr>
           <a:xfrm>
-            <a:off x="457200" y="6547104"/>
+            <a:off x="411480" y="6519672"/>
             <a:ext cx="4114800" cy="182880"/>
           </a:xfrm>
           <a:prstGeom prst="rect">
@@ -4970,10 +4942,10 @@
             <a:r>
               <a:rPr lang="en-US" sz="800" b="1" spc="100" kern="0" dirty="0">
                 <a:solidFill>
-                  <a:srgbClr val="087E73"/>
-                </a:solidFill>
-              </a:rPr>
-              <a:t>FICTIONAL DATA · PILOT DEMO</a:t>
+                  <a:srgbClr val="52525B"/>
+                </a:solidFill>
+              </a:rPr>
+              <a:t>FICTIONAL DATA  /  OCT 2026</a:t>
             </a:r>
             <a:endParaRPr lang="en-US" sz="800" dirty="0"/>
           </a:p>
@@ -4987,8 +4959,8 @@
         </p:nvSpPr>
         <p:spPr>
           <a:xfrm>
-            <a:off x="11155680" y="6510528"/>
-            <a:ext cx="548640" cy="228600"/>
+            <a:off x="11018520" y="6510528"/>
+            <a:ext cx="685800" cy="228600"/>
           </a:xfrm>
           <a:prstGeom prst="rect">
             <a:avLst/>
@@ -5006,10 +4978,10 @@
             <a:r>
               <a:rPr lang="en-US" sz="900" dirty="0">
                 <a:solidFill>
-                  <a:srgbClr val="607984"/>
-                </a:solidFill>
-              </a:rPr>
-              <a:t>07</a:t>
+                  <a:srgbClr val="52525B"/>
+                </a:solidFill>
+              </a:rPr>
+              <a:t>07 / 08</a:t>
             </a:r>
             <a:endParaRPr lang="en-US" sz="900" dirty="0"/>
           </a:p>
@@ -5029,7 +5001,7 @@
     <p:bg>
       <p:bgPr>
         <a:solidFill>
-          <a:srgbClr val="F6F9F9"/>
+          <a:srgbClr val="FAFAFA"/>
         </a:solidFill>
       </p:bgPr>
     </p:bg>
@@ -5056,17 +5028,17 @@
         <p:spPr>
           <a:xfrm>
             <a:off x="0" y="0"/>
-            <a:ext cx="12191695" cy="146304"/>
-          </a:xfrm>
-          <a:prstGeom prst="rect">
-            <a:avLst/>
-          </a:prstGeom>
-          <a:solidFill>
-            <a:srgbClr val="087E73"/>
+            <a:ext cx="109728" cy="6858000"/>
+          </a:xfrm>
+          <a:prstGeom prst="rect">
+            <a:avLst/>
+          </a:prstGeom>
+          <a:solidFill>
+            <a:srgbClr val="4338CA"/>
           </a:solidFill>
           <a:ln w="12700">
             <a:solidFill>
-              <a:srgbClr val="087E73"/>
+              <a:srgbClr val="4338CA"/>
             </a:solidFill>
             <a:prstDash val="solid"/>
           </a:ln>
@@ -5080,8 +5052,8 @@
         </p:nvSpPr>
         <p:spPr>
           <a:xfrm>
-            <a:off x="438912" y="310896"/>
-            <a:ext cx="11064240" cy="384048"/>
+            <a:off x="411480" y="274320"/>
+            <a:ext cx="9144000" cy="182880"/>
           </a:xfrm>
           <a:prstGeom prst="rect">
             <a:avLst/>
@@ -5097,53 +5069,53 @@
               <a:buNone/>
             </a:pPr>
             <a:r>
-              <a:rPr lang="en-US" sz="2500" b="1" dirty="0">
-                <a:solidFill>
-                  <a:srgbClr val="14353E"/>
+              <a:rPr lang="en-US" sz="800" b="1" spc="180" kern="0" dirty="0">
+                <a:solidFill>
+                  <a:srgbClr val="4338CA"/>
+                </a:solidFill>
+              </a:rPr>
+              <a:t>PROJECT MANAGER</a:t>
+            </a:r>
+            <a:endParaRPr lang="en-US" sz="800" dirty="0"/>
+          </a:p>
+        </p:txBody>
+      </p:sp>
+      <p:sp>
+        <p:nvSpPr>
+          <p:cNvPr id="4" name="Text 2"/>
+          <p:cNvSpPr/>
+          <p:nvPr/>
+        </p:nvSpPr>
+        <p:spPr>
+          <a:xfrm>
+            <a:off x="411480" y="530352"/>
+            <a:ext cx="11064240" cy="457200"/>
+          </a:xfrm>
+          <a:prstGeom prst="rect">
+            <a:avLst/>
+          </a:prstGeom>
+          <a:noFill/>
+          <a:ln/>
+        </p:spPr>
+        <p:txBody>
+          <a:bodyPr wrap="square" lIns="0" tIns="0" rIns="0" bIns="0" rtlCol="0" anchor="ctr"/>
+          <a:lstStyle/>
+          <a:p>
+            <a:pPr indent="0" marL="0">
+              <a:buNone/>
+            </a:pPr>
+            <a:r>
+              <a:rPr lang="en-US" sz="2800" b="1" dirty="0">
+                <a:solidFill>
+                  <a:srgbClr val="0A0A0A"/>
                 </a:solidFill>
                 <a:latin typeface="Aptos Display" pitchFamily="34" charset="0"/>
                 <a:ea typeface="Aptos Display" pitchFamily="34" charset="-122"/>
                 <a:cs typeface="Aptos Display" pitchFamily="34" charset="-120"/>
               </a:rPr>
-              <a:t>Reports and deployment readiness</a:t>
-            </a:r>
-            <a:endParaRPr lang="en-US" sz="2500" dirty="0"/>
-          </a:p>
-        </p:txBody>
-      </p:sp>
-      <p:sp>
-        <p:nvSpPr>
-          <p:cNvPr id="4" name="Text 2"/>
-          <p:cNvSpPr/>
-          <p:nvPr/>
-        </p:nvSpPr>
-        <p:spPr>
-          <a:xfrm>
-            <a:off x="457200" y="758952"/>
-            <a:ext cx="10972800" cy="292608"/>
-          </a:xfrm>
-          <a:prstGeom prst="rect">
-            <a:avLst/>
-          </a:prstGeom>
-          <a:noFill/>
-          <a:ln/>
-        </p:spPr>
-        <p:txBody>
-          <a:bodyPr wrap="square" lIns="0" tIns="0" rIns="0" bIns="0" rtlCol="0" anchor="ctr"/>
-          <a:lstStyle/>
-          <a:p>
-            <a:pPr indent="0" marL="0">
-              <a:buNone/>
-            </a:pPr>
-            <a:r>
-              <a:rPr lang="en-US" sz="1050" dirty="0">
-                <a:solidFill>
-                  <a:srgbClr val="607984"/>
-                </a:solidFill>
-              </a:rPr>
-              <a:t>Project Manager report</a:t>
-            </a:r>
-            <a:endParaRPr lang="en-US" sz="1050" dirty="0"/>
+              <a:t>Reports and pilot readiness</a:t>
+            </a:r>
+            <a:endParaRPr lang="en-US" sz="2800" dirty="0"/>
           </a:p>
         </p:txBody>
       </p:sp>
@@ -5155,20 +5127,18 @@
         </p:nvSpPr>
         <p:spPr>
           <a:xfrm>
-            <a:off x="365760" y="1243584"/>
-            <a:ext cx="7818120" cy="5010912"/>
-          </a:xfrm>
-          <a:prstGeom prst="roundRect">
-            <a:avLst>
-              <a:gd name="adj" fmla="val 1825"/>
-            </a:avLst>
+            <a:off x="365760" y="1207008"/>
+            <a:ext cx="7818120" cy="5029200"/>
+          </a:xfrm>
+          <a:prstGeom prst="rect">
+            <a:avLst/>
           </a:prstGeom>
           <a:solidFill>
             <a:srgbClr val="FFFFFF"/>
           </a:solidFill>
           <a:ln w="12700">
             <a:solidFill>
-              <a:srgbClr val="DCE8E8"/>
+              <a:srgbClr val="E4E4E7"/>
             </a:solidFill>
             <a:prstDash val="solid"/>
           </a:ln>
@@ -5190,8 +5160,8 @@
         </p:blipFill>
         <p:spPr>
           <a:xfrm>
-            <a:off x="411480" y="1289304"/>
-            <a:ext cx="7726680" cy="4919472"/>
+            <a:off x="402336" y="1243584"/>
+            <a:ext cx="7744968" cy="4956048"/>
           </a:xfrm>
           <a:prstGeom prst="rect">
             <a:avLst/>
@@ -5206,20 +5176,18 @@
         </p:nvSpPr>
         <p:spPr>
           <a:xfrm>
-            <a:off x="8439912" y="1243584"/>
-            <a:ext cx="3364992" cy="5010912"/>
-          </a:xfrm>
-          <a:prstGeom prst="roundRect">
-            <a:avLst>
-              <a:gd name="adj" fmla="val 2717"/>
-            </a:avLst>
+            <a:off x="8439912" y="1207008"/>
+            <a:ext cx="3364992" cy="5029200"/>
+          </a:xfrm>
+          <a:prstGeom prst="rect">
+            <a:avLst/>
           </a:prstGeom>
           <a:solidFill>
             <a:srgbClr val="FFFFFF"/>
           </a:solidFill>
           <a:ln w="12700">
             <a:solidFill>
-              <a:srgbClr val="DCE8E8"/>
+              <a:srgbClr val="E4E4E7"/>
             </a:solidFill>
             <a:prstDash val="solid"/>
           </a:ln>
@@ -5233,8 +5201,8 @@
         </p:nvSpPr>
         <p:spPr>
           <a:xfrm>
-            <a:off x="8686800" y="1536192"/>
-            <a:ext cx="2834640" cy="320040"/>
+            <a:off x="8686800" y="1545336"/>
+            <a:ext cx="2834640" cy="210312"/>
           </a:xfrm>
           <a:prstGeom prst="rect">
             <a:avLst/>
@@ -5250,14 +5218,14 @@
               <a:buNone/>
             </a:pPr>
             <a:r>
-              <a:rPr lang="en-US" sz="1500" b="1" dirty="0">
-                <a:solidFill>
-                  <a:srgbClr val="14353E"/>
-                </a:solidFill>
-              </a:rPr>
-              <a:t>What this shows</a:t>
-            </a:r>
-            <a:endParaRPr lang="en-US" sz="1500" dirty="0"/>
+              <a:rPr lang="en-US" sz="900" b="1" spc="160" kern="0" dirty="0">
+                <a:solidFill>
+                  <a:srgbClr val="4338CA"/>
+                </a:solidFill>
+              </a:rPr>
+              <a:t>IN THIS VIEW</a:t>
+            </a:r>
+            <a:endParaRPr lang="en-US" sz="900" dirty="0"/>
           </a:p>
         </p:txBody>
       </p:sp>
@@ -5269,18 +5237,18 @@
         </p:nvSpPr>
         <p:spPr>
           <a:xfrm>
-            <a:off x="8695944" y="2112264"/>
-            <a:ext cx="91440" cy="91440"/>
-          </a:xfrm>
-          <a:prstGeom prst="ellipse">
-            <a:avLst/>
-          </a:prstGeom>
-          <a:solidFill>
-            <a:srgbClr val="087E73"/>
+            <a:off x="8695944" y="2066544"/>
+            <a:ext cx="73152" cy="73152"/>
+          </a:xfrm>
+          <a:prstGeom prst="rect">
+            <a:avLst/>
+          </a:prstGeom>
+          <a:solidFill>
+            <a:srgbClr val="4338CA"/>
           </a:solidFill>
           <a:ln w="12700">
             <a:solidFill>
-              <a:srgbClr val="087E73"/>
+              <a:srgbClr val="4338CA"/>
             </a:solidFill>
             <a:prstDash val="solid"/>
           </a:ln>
@@ -5294,8 +5262,8 @@
         </p:nvSpPr>
         <p:spPr>
           <a:xfrm>
-            <a:off x="8915400" y="2057400"/>
-            <a:ext cx="2606040" cy="758952"/>
+            <a:off x="8915400" y="2011680"/>
+            <a:ext cx="2606040" cy="850392"/>
           </a:xfrm>
           <a:prstGeom prst="rect">
             <a:avLst/>
@@ -5313,14 +5281,14 @@
               <a:buNone/>
             </a:pPr>
             <a:r>
-              <a:rPr lang="en-US" sz="1200" dirty="0">
-                <a:solidFill>
-                  <a:srgbClr val="14353E"/>
-                </a:solidFill>
-              </a:rPr>
-              <a:t>Overdue Tasks and Project Progress support filters and CSV.</a:t>
-            </a:r>
-            <a:endParaRPr lang="en-US" sz="1200" dirty="0"/>
+              <a:rPr lang="en-US" sz="1250" dirty="0">
+                <a:solidFill>
+                  <a:srgbClr val="0A0A0A"/>
+                </a:solidFill>
+              </a:rPr>
+              <a:t>Overdue Tasks and Project Progress offer CSV export.</a:t>
+            </a:r>
+            <a:endParaRPr lang="en-US" sz="1250" dirty="0"/>
           </a:p>
         </p:txBody>
       </p:sp>
@@ -5332,18 +5300,18 @@
         </p:nvSpPr>
         <p:spPr>
           <a:xfrm>
-            <a:off x="8695944" y="3118104"/>
-            <a:ext cx="91440" cy="91440"/>
-          </a:xfrm>
-          <a:prstGeom prst="ellipse">
-            <a:avLst/>
-          </a:prstGeom>
-          <a:solidFill>
-            <a:srgbClr val="087E73"/>
+            <a:off x="8695944" y="3300984"/>
+            <a:ext cx="73152" cy="73152"/>
+          </a:xfrm>
+          <a:prstGeom prst="rect">
+            <a:avLst/>
+          </a:prstGeom>
+          <a:solidFill>
+            <a:srgbClr val="4338CA"/>
           </a:solidFill>
           <a:ln w="12700">
             <a:solidFill>
-              <a:srgbClr val="087E73"/>
+              <a:srgbClr val="4338CA"/>
             </a:solidFill>
             <a:prstDash val="solid"/>
           </a:ln>
@@ -5357,8 +5325,8 @@
         </p:nvSpPr>
         <p:spPr>
           <a:xfrm>
-            <a:off x="8915400" y="3063240"/>
-            <a:ext cx="2606040" cy="758952"/>
+            <a:off x="8915400" y="3246120"/>
+            <a:ext cx="2606040" cy="850392"/>
           </a:xfrm>
           <a:prstGeom prst="rect">
             <a:avLst/>
@@ -5376,14 +5344,14 @@
               <a:buNone/>
             </a:pPr>
             <a:r>
-              <a:rPr lang="en-US" sz="1200" dirty="0">
-                <a:solidFill>
-                  <a:srgbClr val="14353E"/>
-                </a:solidFill>
-              </a:rPr>
-              <a:t>Local browser and API workflows have been verified.</a:t>
-            </a:r>
-            <a:endParaRPr lang="en-US" sz="1200" dirty="0"/>
+              <a:rPr lang="en-US" sz="1250" dirty="0">
+                <a:solidFill>
+                  <a:srgbClr val="0A0A0A"/>
+                </a:solidFill>
+              </a:rPr>
+              <a:t>The HTTPS demo runs on biztel-ai-cvrde.vercel.app.</a:t>
+            </a:r>
+            <a:endParaRPr lang="en-US" sz="1250" dirty="0"/>
           </a:p>
         </p:txBody>
       </p:sp>
@@ -5395,18 +5363,18 @@
         </p:nvSpPr>
         <p:spPr>
           <a:xfrm>
-            <a:off x="8695944" y="4123944"/>
-            <a:ext cx="91440" cy="91440"/>
-          </a:xfrm>
-          <a:prstGeom prst="ellipse">
-            <a:avLst/>
-          </a:prstGeom>
-          <a:solidFill>
-            <a:srgbClr val="087E73"/>
+            <a:off x="8695944" y="4535424"/>
+            <a:ext cx="73152" cy="73152"/>
+          </a:xfrm>
+          <a:prstGeom prst="rect">
+            <a:avLst/>
+          </a:prstGeom>
+          <a:solidFill>
+            <a:srgbClr val="4338CA"/>
           </a:solidFill>
           <a:ln w="12700">
             <a:solidFill>
-              <a:srgbClr val="087E73"/>
+              <a:srgbClr val="4338CA"/>
             </a:solidFill>
             <a:prstDash val="solid"/>
           </a:ln>
@@ -5420,8 +5388,8 @@
         </p:nvSpPr>
         <p:spPr>
           <a:xfrm>
-            <a:off x="8915400" y="4069080"/>
-            <a:ext cx="2606040" cy="758952"/>
+            <a:off x="8915400" y="4480560"/>
+            <a:ext cx="2606040" cy="850392"/>
           </a:xfrm>
           <a:prstGeom prst="rect">
             <a:avLst/>
@@ -5439,14 +5407,14 @@
               <a:buNone/>
             </a:pPr>
             <a:r>
-              <a:rPr lang="en-US" sz="1200" dirty="0">
-                <a:solidFill>
-                  <a:srgbClr val="14353E"/>
-                </a:solidFill>
-              </a:rPr>
-              <a:t>Cloud VM, Neon, HTTPS, and email delivery need deployment settings.</a:t>
-            </a:r>
-            <a:endParaRPr lang="en-US" sz="1200" dirty="0"/>
+              <a:rPr lang="en-US" sz="1250" dirty="0">
+                <a:solidFill>
+                  <a:srgbClr val="0A0A0A"/>
+                </a:solidFill>
+              </a:rPr>
+              <a:t>SMTP delivery requires controlled inboxes and settings.</a:t>
+            </a:r>
+            <a:endParaRPr lang="en-US" sz="1250" dirty="0"/>
           </a:p>
         </p:txBody>
       </p:sp>
@@ -5458,7 +5426,7 @@
         </p:nvSpPr>
         <p:spPr>
           <a:xfrm>
-            <a:off x="457200" y="6547104"/>
+            <a:off x="411480" y="6519672"/>
             <a:ext cx="4114800" cy="182880"/>
           </a:xfrm>
           <a:prstGeom prst="rect">
@@ -5477,10 +5445,10 @@
             <a:r>
               <a:rPr lang="en-US" sz="800" b="1" spc="100" kern="0" dirty="0">
                 <a:solidFill>
-                  <a:srgbClr val="087E73"/>
-                </a:solidFill>
-              </a:rPr>
-              <a:t>FICTIONAL DATA · PILOT DEMO</a:t>
+                  <a:srgbClr val="52525B"/>
+                </a:solidFill>
+              </a:rPr>
+              <a:t>FICTIONAL DATA  /  OCT 2026</a:t>
             </a:r>
             <a:endParaRPr lang="en-US" sz="800" dirty="0"/>
           </a:p>
@@ -5494,8 +5462,8 @@
         </p:nvSpPr>
         <p:spPr>
           <a:xfrm>
-            <a:off x="11155680" y="6510528"/>
-            <a:ext cx="548640" cy="228600"/>
+            <a:off x="11018520" y="6510528"/>
+            <a:ext cx="685800" cy="228600"/>
           </a:xfrm>
           <a:prstGeom prst="rect">
             <a:avLst/>
@@ -5513,10 +5481,10 @@
             <a:r>
               <a:rPr lang="en-US" sz="900" dirty="0">
                 <a:solidFill>
-                  <a:srgbClr val="607984"/>
-                </a:solidFill>
-              </a:rPr>
-              <a:t>08</a:t>
+                  <a:srgbClr val="52525B"/>
+                </a:solidFill>
+              </a:rPr>
+              <a:t>08 / 08</a:t>
             </a:r>
             <a:endParaRPr lang="en-US" sz="900" dirty="0"/>
           </a:p>

</xml_diff>

<commit_message>
Refine task workflow, team settings and review UI
</commit_message>
<xml_diff>
--- a/docs/CVRDE_Demo_Presentation.pptx
+++ b/docs/CVRDE_Demo_Presentation.pptx
@@ -2559,7 +2559,7 @@
                   <a:srgbClr val="4338CA"/>
                 </a:solidFill>
               </a:rPr>
-              <a:t>PROJECT MANAGER</a:t>
+              <a:t>PROJECT MANAGER SETTINGS</a:t>
             </a:r>
             <a:endParaRPr lang="en-US" sz="800" dirty="0"/>
           </a:p>
@@ -2598,7 +2598,7 @@
                 <a:ea typeface="Aptos Display" pitchFamily="34" charset="-122"/>
                 <a:cs typeface="Aptos Display" pitchFamily="34" charset="-120"/>
               </a:rPr>
-              <a:t>Projects and controlled sharing</a:t>
+              <a:t>Project setup and groups</a:t>
             </a:r>
             <a:endParaRPr lang="en-US" sz="2800" dirty="0"/>
           </a:p>
@@ -2771,7 +2771,7 @@
                   <a:srgbClr val="0A0A0A"/>
                 </a:solidFill>
               </a:rPr>
-              <a:t>Create projects, parent tasks, and assigned work.</a:t>
+              <a:t>Create projects and add existing team members.</a:t>
             </a:r>
             <a:endParaRPr lang="en-US" sz="1250" dirty="0"/>
           </a:p>
@@ -2834,7 +2834,7 @@
                   <a:srgbClr val="0A0A0A"/>
                 </a:solidFill>
               </a:rPr>
-              <a:t>Groups control member access and task sharing.</a:t>
+              <a:t>Add groups manually or import an Excel sheet.</a:t>
             </a:r>
             <a:endParaRPr lang="en-US" sz="1250" dirty="0"/>
           </a:p>
@@ -2897,7 +2897,7 @@
                   <a:srgbClr val="0A0A0A"/>
                 </a:solidFill>
               </a:rPr>
-              <a:t>Permissions apply to the API as well as the interface.</a:t>
+              <a:t>Group permissions control shared work.</a:t>
             </a:r>
             <a:endParaRPr lang="en-US" sz="1250" dirty="0"/>
           </a:p>
@@ -3274,7 +3274,7 @@
                   <a:srgbClr val="0A0A0A"/>
                 </a:solidFill>
               </a:rPr>
-              <a:t>Members see owned tasks and work shared through groups.</a:t>
+              <a:t>The table shows task, due date, and linked work.</a:t>
             </a:r>
             <a:endParaRPr lang="en-US" sz="1250" dirty="0"/>
           </a:p>
@@ -3337,7 +3337,7 @@
                   <a:srgbClr val="0A0A0A"/>
                 </a:solidFill>
               </a:rPr>
-              <a:t>They update progress and submit results.</a:t>
+              <a:t>Members see owned and permitted shared tasks.</a:t>
             </a:r>
             <a:endParaRPr lang="en-US" sz="1250" dirty="0"/>
           </a:p>
@@ -3400,7 +3400,7 @@
                   <a:srgbClr val="0A0A0A"/>
                 </a:solidFill>
               </a:rPr>
-              <a:t>Private work stays outside other members’ views.</a:t>
+              <a:t>Status and results are updated inside task detail.</a:t>
             </a:r>
             <a:endParaRPr lang="en-US" sz="1250" dirty="0"/>
           </a:p>
@@ -3777,7 +3777,7 @@
                   <a:srgbClr val="0A0A0A"/>
                 </a:solidFill>
               </a:rPr>
-              <a:t>Submitted results can be returned, revised, and accepted.</a:t>
+              <a:t>Status changes through a dropdown.</a:t>
             </a:r>
             <a:endParaRPr lang="en-US" sz="1250" dirty="0"/>
           </a:p>
@@ -3840,7 +3840,7 @@
                   <a:srgbClr val="0A0A0A"/>
                 </a:solidFill>
               </a:rPr>
-              <a:t>Document versions remain available to authorized users.</a:t>
+              <a:t>A single description submits each result version.</a:t>
             </a:r>
             <a:endParaRPr lang="en-US" sz="1250" dirty="0"/>
           </a:p>
@@ -3903,7 +3903,7 @@
                   <a:srgbClr val="0A0A0A"/>
                 </a:solidFill>
               </a:rPr>
-              <a:t>Task history records the sequence of changes.</a:t>
+              <a:t>Prerequisites and reassignment live in task detail.</a:t>
             </a:r>
             <a:endParaRPr lang="en-US" sz="1250" dirty="0"/>
           </a:p>
@@ -4107,7 +4107,7 @@
                 <a:ea typeface="Aptos Display" pitchFamily="34" charset="-122"/>
                 <a:cs typeface="Aptos Display" pitchFamily="34" charset="-120"/>
               </a:rPr>
-              <a:t>Pending decisions</a:t>
+              <a:t>Review and approvals</a:t>
             </a:r>
             <a:endParaRPr lang="en-US" sz="2800" dirty="0"/>
           </a:p>
@@ -4280,7 +4280,7 @@
                   <a:srgbClr val="0A0A0A"/>
                 </a:solidFill>
               </a:rPr>
-              <a:t>Result reviews and due date requests appear in one queue.</a:t>
+              <a:t>Filter decisions by request type and task.</a:t>
             </a:r>
             <a:endParaRPr lang="en-US" sz="1250" dirty="0"/>
           </a:p>
@@ -4343,7 +4343,7 @@
                   <a:srgbClr val="0A0A0A"/>
                 </a:solidFill>
               </a:rPr>
-              <a:t>Approval or rejection updates the task and history.</a:t>
+              <a:t>Managers decide employee reassignment requests.</a:t>
             </a:r>
             <a:endParaRPr lang="en-US" sz="1250" dirty="0"/>
           </a:p>
@@ -4406,7 +4406,7 @@
                   <a:srgbClr val="0A0A0A"/>
                 </a:solidFill>
               </a:rPr>
-              <a:t>Completed decisions leave the queue.</a:t>
+              <a:t>Results, extensions, and prerequisites share one queue.</a:t>
             </a:r>
             <a:endParaRPr lang="en-US" sz="1250" dirty="0"/>
           </a:p>
@@ -4783,7 +4783,7 @@
                   <a:srgbClr val="0A0A0A"/>
                 </a:solidFill>
               </a:rPr>
-              <a:t>A reassignment request is routed to the reviewer.</a:t>
+              <a:t>A PM reassignment request reaches the reviewer.</a:t>
             </a:r>
             <a:endParaRPr lang="en-US" sz="1250" dirty="0"/>
           </a:p>
@@ -4846,7 +4846,7 @@
                   <a:srgbClr val="0A0A0A"/>
                 </a:solidFill>
               </a:rPr>
-              <a:t>Approval changes ownership; rejection retains it.</a:t>
+              <a:t>The reason and work window are visible before a decision.</a:t>
             </a:r>
             <a:endParaRPr lang="en-US" sz="1250" dirty="0"/>
           </a:p>
@@ -4909,7 +4909,7 @@
                   <a:srgbClr val="0A0A0A"/>
                 </a:solidFill>
               </a:rPr>
-              <a:t>The action is recorded for audit and reporting.</a:t>
+              <a:t>Approval changes ownership; rejection retains it.</a:t>
             </a:r>
             <a:endParaRPr lang="en-US" sz="1250" dirty="0"/>
           </a:p>

</xml_diff>

<commit_message>
Align CVRDE demo with approved review scope
</commit_message>
<xml_diff>
--- a/docs/CVRDE_Demo_Presentation.pptx
+++ b/docs/CVRDE_Demo_Presentation.pptx
@@ -13,9 +13,10 @@
     <p:sldId id="261" r:id="rId7"/>
     <p:sldId id="262" r:id="rId8"/>
     <p:sldId id="263" r:id="rId9"/>
+    <p:sldId id="264" r:id="rId10"/>
   </p:sldIdLst>
   <p:notesMasterIdLst>
-    <p:notesMasterId r:id="rId10"/>
+    <p:notesMasterId r:id="rId11"/>
   </p:notesMasterIdLst>
   <p:sldSz cx="12192000" cy="6858000"/>
   <p:notesSz cx="6858000" cy="12192000"/>
@@ -1167,6 +1168,94 @@
 </p:notes>
 </file>
 
+<file path=ppt/notesSlides/notesSlide9.xml><?xml version="1.0" encoding="utf-8"?>
+<p:notes xmlns:a="http://schemas.openxmlformats.org/drawingml/2006/main" xmlns:r="http://schemas.openxmlformats.org/officeDocument/2006/relationships" xmlns:p="http://schemas.openxmlformats.org/presentationml/2006/main">
+  <p:cSld>
+    <p:spTree>
+      <p:nvGrpSpPr>
+        <p:cNvPr id="1" name=""/>
+        <p:cNvGrpSpPr/>
+        <p:nvPr/>
+      </p:nvGrpSpPr>
+      <p:grpSpPr>
+        <a:xfrm>
+          <a:off x="0" y="0"/>
+          <a:ext cx="0" cy="0"/>
+          <a:chOff x="0" y="0"/>
+          <a:chExt cx="0" cy="0"/>
+        </a:xfrm>
+      </p:grpSpPr>
+      <p:sp>
+        <p:nvSpPr>
+          <p:cNvPr id="2" name="Slide Image Placeholder 1"/>
+          <p:cNvSpPr>
+            <a:spLocks noGrp="1" noRot="1" noChangeAspect="1"/>
+          </p:cNvSpPr>
+          <p:nvPr>
+            <p:ph type="sldImg"/>
+          </p:nvPr>
+        </p:nvSpPr>
+        <p:spPr/>
+      </p:sp>
+      <p:sp>
+        <p:nvSpPr>
+          <p:cNvPr id="3" name="Notes Placeholder 2"/>
+          <p:cNvSpPr>
+            <a:spLocks noGrp="1"/>
+          </p:cNvSpPr>
+          <p:nvPr>
+            <p:ph type="body" idx="1"/>
+          </p:nvPr>
+        </p:nvSpPr>
+        <p:spPr/>
+        <p:txBody>
+          <a:bodyPr/>
+          <a:lstStyle/>
+          <a:p>
+            <a:r>
+              <a:rPr lang="en-US" dirty="0"/>
+              <a:t/>
+            </a:r>
+            <a:endParaRPr lang="en-US" dirty="0"/>
+          </a:p>
+        </p:txBody>
+      </p:sp>
+      <p:sp>
+        <p:nvSpPr>
+          <p:cNvPr id="4" name="Slide Number Placeholder 3"/>
+          <p:cNvSpPr>
+            <a:spLocks noGrp="1"/>
+          </p:cNvSpPr>
+          <p:nvPr>
+            <p:ph type="sldNum" sz="quarter" idx="10"/>
+          </p:nvPr>
+        </p:nvSpPr>
+        <p:spPr/>
+        <p:txBody>
+          <a:bodyPr/>
+          <a:lstStyle/>
+          <a:p>
+            <a:fld id="{F7021451-1387-4CA6-816F-3879F97B5CBC}" type="slidenum">
+              <a:rPr lang="en-US"/>
+              <a:t>9</a:t>
+            </a:fld>
+            <a:endParaRPr lang="en-US"/>
+          </a:p>
+        </p:txBody>
+      </p:sp>
+    </p:spTree>
+    <p:extLst>
+      <p:ext uri="{BB962C8B-B14F-4D97-AF65-F5344CB8AC3E}">
+        <p14:creationId xmlns:p14="http://schemas.microsoft.com/office/powerpoint/2010/main" val="1024086991"/>
+      </p:ext>
+    </p:extLst>
+  </p:cSld>
+  <p:clrMapOvr>
+    <a:masterClrMapping/>
+  </p:clrMapOvr>
+</p:notes>
+</file>
+
 <file path=ppt/slideLayouts/slideLayout1.xml><?xml version="1.0" encoding="utf-8"?>
 <p:sldLayout xmlns:a="http://schemas.openxmlformats.org/drawingml/2006/main" xmlns:r="http://schemas.openxmlformats.org/officeDocument/2006/relationships" xmlns:p="http://schemas.openxmlformats.org/presentationml/2006/main" preserve="1">
   <p:cSld name="DEFAULT">
@@ -1963,7 +2052,7 @@
                   <a:srgbClr val="52525B"/>
                 </a:solidFill>
               </a:rPr>
-              <a:t>01 / 08</a:t>
+              <a:t>01 / 09</a:t>
             </a:r>
             <a:endParaRPr lang="en-US" sz="900" dirty="0"/>
           </a:p>
@@ -2268,7 +2357,7 @@
                   <a:srgbClr val="0A0A0A"/>
                 </a:solidFill>
               </a:rPr>
-              <a:t>Dashboard totals come from current task and approval data.</a:t>
+              <a:t>Three sub-projects are at different stages.</a:t>
             </a:r>
             <a:endParaRPr lang="en-US" sz="1250" dirty="0"/>
           </a:p>
@@ -2331,7 +2420,7 @@
                   <a:srgbClr val="0A0A0A"/>
                 </a:solidFill>
               </a:rPr>
-              <a:t>Seventeen seeded tasks cover varied owners and deadlines.</a:t>
+              <a:t>Risk shows overdue, due soon, and stale tasks.</a:t>
             </a:r>
             <a:endParaRPr lang="en-US" sz="1250" dirty="0"/>
           </a:p>
@@ -2394,7 +2483,7 @@
                   <a:srgbClr val="0A0A0A"/>
                 </a:solidFill>
               </a:rPr>
-              <a:t>Decision and overdue lists lead to the underlying work.</a:t>
+              <a:t>Decisions and progress lead to the underlying work.</a:t>
             </a:r>
             <a:endParaRPr lang="en-US" sz="1250" dirty="0"/>
           </a:p>
@@ -2466,7 +2555,7 @@
                   <a:srgbClr val="52525B"/>
                 </a:solidFill>
               </a:rPr>
-              <a:t>02 / 08</a:t>
+              <a:t>02 / 09</a:t>
             </a:r>
             <a:endParaRPr lang="en-US" sz="900" dirty="0"/>
           </a:p>
@@ -2559,7 +2648,7 @@
                   <a:srgbClr val="4338CA"/>
                 </a:solidFill>
               </a:rPr>
-              <a:t>PROJECT MANAGER SETTINGS</a:t>
+              <a:t>PROJECT MANAGER</a:t>
             </a:r>
             <a:endParaRPr lang="en-US" sz="800" dirty="0"/>
           </a:p>
@@ -2598,7 +2687,7 @@
                 <a:ea typeface="Aptos Display" pitchFamily="34" charset="-122"/>
                 <a:cs typeface="Aptos Display" pitchFamily="34" charset="-120"/>
               </a:rPr>
-              <a:t>Project setup and groups</a:t>
+              <a:t>Project structure</a:t>
             </a:r>
             <a:endParaRPr lang="en-US" sz="2800" dirty="0"/>
           </a:p>
@@ -2771,7 +2860,7 @@
                   <a:srgbClr val="0A0A0A"/>
                 </a:solidFill>
               </a:rPr>
-              <a:t>Create projects and add existing team members.</a:t>
+              <a:t>Project → Sub-project → Task.</a:t>
             </a:r>
             <a:endParaRPr lang="en-US" sz="1250" dirty="0"/>
           </a:p>
@@ -2834,7 +2923,7 @@
                   <a:srgbClr val="0A0A0A"/>
                 </a:solidFill>
               </a:rPr>
-              <a:t>Add groups manually or import an Excel sheet.</a:t>
+              <a:t>PM sets each sub-project objective, owner, and due date.</a:t>
             </a:r>
             <a:endParaRPr lang="en-US" sz="1250" dirty="0"/>
           </a:p>
@@ -2897,7 +2986,7 @@
                   <a:srgbClr val="0A0A0A"/>
                 </a:solidFill>
               </a:rPr>
-              <a:t>Group permissions control shared work.</a:t>
+              <a:t>Sub-project owners assign tasks within their scope.</a:t>
             </a:r>
             <a:endParaRPr lang="en-US" sz="1250" dirty="0"/>
           </a:p>
@@ -2969,7 +3058,7 @@
                   <a:srgbClr val="52525B"/>
                 </a:solidFill>
               </a:rPr>
-              <a:t>03 / 08</a:t>
+              <a:t>03 / 09</a:t>
             </a:r>
             <a:endParaRPr lang="en-US" sz="900" dirty="0"/>
           </a:p>
@@ -3062,7 +3151,7 @@
                   <a:srgbClr val="4338CA"/>
                 </a:solidFill>
               </a:rPr>
-              <a:t>SCIENTIST ONE</a:t>
+              <a:t>MY WORK</a:t>
             </a:r>
             <a:endParaRPr lang="en-US" sz="800" dirty="0"/>
           </a:p>
@@ -3101,7 +3190,7 @@
                 <a:ea typeface="Aptos Display" pitchFamily="34" charset="-122"/>
                 <a:cs typeface="Aptos Display" pitchFamily="34" charset="-120"/>
               </a:rPr>
-              <a:t>Scientist workspace</a:t>
+              <a:t>Task owner workspace</a:t>
             </a:r>
             <a:endParaRPr lang="en-US" sz="2800" dirty="0"/>
           </a:p>
@@ -3274,7 +3363,7 @@
                   <a:srgbClr val="0A0A0A"/>
                 </a:solidFill>
               </a:rPr>
-              <a:t>The table shows task, due date, and linked work.</a:t>
+              <a:t>Owned tasks are grouped by when action is due.</a:t>
             </a:r>
             <a:endParaRPr lang="en-US" sz="1250" dirty="0"/>
           </a:p>
@@ -3337,7 +3426,7 @@
                   <a:srgbClr val="0A0A0A"/>
                 </a:solidFill>
               </a:rPr>
-              <a:t>Members see owned and permitted shared tasks.</a:t>
+              <a:t>Returned work shows the reviewer reason.</a:t>
             </a:r>
             <a:endParaRPr lang="en-US" sz="1250" dirty="0"/>
           </a:p>
@@ -3400,7 +3489,7 @@
                   <a:srgbClr val="0A0A0A"/>
                 </a:solidFill>
               </a:rPr>
-              <a:t>Status and results are updated inside task detail.</a:t>
+              <a:t>Submitted work waits for review.</a:t>
             </a:r>
             <a:endParaRPr lang="en-US" sz="1250" dirty="0"/>
           </a:p>
@@ -3472,7 +3561,7 @@
                   <a:srgbClr val="52525B"/>
                 </a:solidFill>
               </a:rPr>
-              <a:t>04 / 08</a:t>
+              <a:t>04 / 09</a:t>
             </a:r>
             <a:endParaRPr lang="en-US" sz="900" dirty="0"/>
           </a:p>
@@ -3777,7 +3866,7 @@
                   <a:srgbClr val="0A0A0A"/>
                 </a:solidFill>
               </a:rPr>
-              <a:t>Status changes through a dropdown.</a:t>
+              <a:t>Start, attach a report, and submit a result.</a:t>
             </a:r>
             <a:endParaRPr lang="en-US" sz="1250" dirty="0"/>
           </a:p>
@@ -3840,7 +3929,7 @@
                   <a:srgbClr val="0A0A0A"/>
                 </a:solidFill>
               </a:rPr>
-              <a:t>A single description submits each result version.</a:t>
+              <a:t>Reviewers return with a reason or sign off.</a:t>
             </a:r>
             <a:endParaRPr lang="en-US" sz="1250" dirty="0"/>
           </a:p>
@@ -3903,7 +3992,7 @@
                   <a:srgbClr val="0A0A0A"/>
                 </a:solidFill>
               </a:rPr>
-              <a:t>Prerequisites and reassignment live in task detail.</a:t>
+              <a:t>Activity explains each change in plain language.</a:t>
             </a:r>
             <a:endParaRPr lang="en-US" sz="1250" dirty="0"/>
           </a:p>
@@ -3975,7 +4064,7 @@
                   <a:srgbClr val="52525B"/>
                 </a:solidFill>
               </a:rPr>
-              <a:t>05 / 08</a:t>
+              <a:t>05 / 09</a:t>
             </a:r>
             <a:endParaRPr lang="en-US" sz="900" dirty="0"/>
           </a:p>
@@ -4068,7 +4157,7 @@
                   <a:srgbClr val="4338CA"/>
                 </a:solidFill>
               </a:rPr>
-              <a:t>PROJECT MANAGER</a:t>
+              <a:t>SUB-PROJECT OWNER</a:t>
             </a:r>
             <a:endParaRPr lang="en-US" sz="800" dirty="0"/>
           </a:p>
@@ -4107,7 +4196,7 @@
                 <a:ea typeface="Aptos Display" pitchFamily="34" charset="-122"/>
                 <a:cs typeface="Aptos Display" pitchFamily="34" charset="-120"/>
               </a:rPr>
-              <a:t>Review and approvals</a:t>
+              <a:t>Evidence review</a:t>
             </a:r>
             <a:endParaRPr lang="en-US" sz="2800" dirty="0"/>
           </a:p>
@@ -4280,7 +4369,7 @@
                   <a:srgbClr val="0A0A0A"/>
                 </a:solidFill>
               </a:rPr>
-              <a:t>Filter decisions by request type and task.</a:t>
+              <a:t>Submitted evidence is visible in the review queue.</a:t>
             </a:r>
             <a:endParaRPr lang="en-US" sz="1250" dirty="0"/>
           </a:p>
@@ -4343,7 +4432,7 @@
                   <a:srgbClr val="0A0A0A"/>
                 </a:solidFill>
               </a:rPr>
-              <a:t>Managers decide employee reassignment requests.</a:t>
+              <a:t>Return requires a reason and alerts the task owner.</a:t>
             </a:r>
             <a:endParaRPr lang="en-US" sz="1250" dirty="0"/>
           </a:p>
@@ -4406,7 +4495,7 @@
                   <a:srgbClr val="0A0A0A"/>
                 </a:solidFill>
               </a:rPr>
-              <a:t>Results, extensions, and prerequisites share one queue.</a:t>
+              <a:t>Sign-off increases sub-project progress.</a:t>
             </a:r>
             <a:endParaRPr lang="en-US" sz="1250" dirty="0"/>
           </a:p>
@@ -4478,7 +4567,7 @@
                   <a:srgbClr val="52525B"/>
                 </a:solidFill>
               </a:rPr>
-              <a:t>06 / 08</a:t>
+              <a:t>06 / 09</a:t>
             </a:r>
             <a:endParaRPr lang="en-US" sz="900" dirty="0"/>
           </a:p>
@@ -4571,7 +4660,7 @@
                   <a:srgbClr val="4338CA"/>
                 </a:solidFill>
               </a:rPr>
-              <a:t>REVIEWER</a:t>
+              <a:t>PROJECT MANAGER</a:t>
             </a:r>
             <a:endParaRPr lang="en-US" sz="800" dirty="0"/>
           </a:p>
@@ -4610,7 +4699,7 @@
                 <a:ea typeface="Aptos Display" pitchFamily="34" charset="-122"/>
                 <a:cs typeface="Aptos Display" pitchFamily="34" charset="-120"/>
               </a:rPr>
-              <a:t>Independent reviewer</a:t>
+              <a:t>Meeting follow-up</a:t>
             </a:r>
             <a:endParaRPr lang="en-US" sz="2800" dirty="0"/>
           </a:p>
@@ -4783,7 +4872,7 @@
                   <a:srgbClr val="0A0A0A"/>
                 </a:solidFill>
               </a:rPr>
-              <a:t>A PM reassignment request reaches the reviewer.</a:t>
+              <a:t>Record minutes and assign an action item.</a:t>
             </a:r>
             <a:endParaRPr lang="en-US" sz="1250" dirty="0"/>
           </a:p>
@@ -4846,7 +4935,7 @@
                   <a:srgbClr val="0A0A0A"/>
                 </a:solidFill>
               </a:rPr>
-              <a:t>The reason and work window are visible before a decision.</a:t>
+              <a:t>The action appears in its owner’s My work.</a:t>
             </a:r>
             <a:endParaRPr lang="en-US" sz="1250" dirty="0"/>
           </a:p>
@@ -4909,7 +4998,7 @@
                   <a:srgbClr val="0A0A0A"/>
                 </a:solidFill>
               </a:rPr>
-              <a:t>Approval changes ownership; rejection retains it.</a:t>
+              <a:t>The owner receives an assignment notification.</a:t>
             </a:r>
             <a:endParaRPr lang="en-US" sz="1250" dirty="0"/>
           </a:p>
@@ -4981,7 +5070,7 @@
                   <a:srgbClr val="52525B"/>
                 </a:solidFill>
               </a:rPr>
-              <a:t>07 / 08</a:t>
+              <a:t>07 / 09</a:t>
             </a:r>
             <a:endParaRPr lang="en-US" sz="900" dirty="0"/>
           </a:p>
@@ -5074,7 +5163,7 @@
                   <a:srgbClr val="4338CA"/>
                 </a:solidFill>
               </a:rPr>
-              <a:t>PROJECT MANAGER</a:t>
+              <a:t>HOSTED DEMO</a:t>
             </a:r>
             <a:endParaRPr lang="en-US" sz="800" dirty="0"/>
           </a:p>
@@ -5113,7 +5202,7 @@
                 <a:ea typeface="Aptos Display" pitchFamily="34" charset="-122"/>
                 <a:cs typeface="Aptos Display" pitchFamily="34" charset="-120"/>
               </a:rPr>
-              <a:t>Reports and pilot readiness</a:t>
+              <a:t>Pilot readiness</a:t>
             </a:r>
             <a:endParaRPr lang="en-US" sz="2800" dirty="0"/>
           </a:p>
@@ -5286,7 +5375,7 @@
                   <a:srgbClr val="0A0A0A"/>
                 </a:solidFill>
               </a:rPr>
-              <a:t>Overdue Tasks and Project Progress offer CSV export.</a:t>
+              <a:t>The eight-step loop runs on the hosted build.</a:t>
             </a:r>
             <a:endParaRPr lang="en-US" sz="1250" dirty="0"/>
           </a:p>
@@ -5349,7 +5438,7 @@
                   <a:srgbClr val="0A0A0A"/>
                 </a:solidFill>
               </a:rPr>
-              <a:t>The HTTPS demo runs on biztel-ai-cvrde.vercel.app.</a:t>
+              <a:t>Email uses Resend with a redirected team inbox.</a:t>
             </a:r>
             <a:endParaRPr lang="en-US" sz="1250" dirty="0"/>
           </a:p>
@@ -5412,7 +5501,7 @@
                   <a:srgbClr val="0A0A0A"/>
                 </a:solidFill>
               </a:rPr>
-              <a:t>SMTP delivery requires controlled inboxes and settings.</a:t>
+              <a:t>Live delivery check follows deployment configuration.</a:t>
             </a:r>
             <a:endParaRPr lang="en-US" sz="1250" dirty="0"/>
           </a:p>
@@ -5484,7 +5573,516 @@
                   <a:srgbClr val="52525B"/>
                 </a:solidFill>
               </a:rPr>
-              <a:t>08 / 08</a:t>
+              <a:t>08 / 09</a:t>
+            </a:r>
+            <a:endParaRPr lang="en-US" sz="900" dirty="0"/>
+          </a:p>
+        </p:txBody>
+      </p:sp>
+    </p:spTree>
+  </p:cSld>
+  <p:clrMapOvr>
+    <a:masterClrMapping/>
+  </p:clrMapOvr>
+</p:sld>
+</file>
+
+<file path=ppt/slides/slide9.xml><?xml version="1.0" encoding="utf-8"?>
+<p:sld xmlns:a="http://schemas.openxmlformats.org/drawingml/2006/main" xmlns:r="http://schemas.openxmlformats.org/officeDocument/2006/relationships" xmlns:p="http://schemas.openxmlformats.org/presentationml/2006/main">
+  <p:cSld name="Slide 9">
+    <p:bg>
+      <p:bgPr>
+        <a:solidFill>
+          <a:srgbClr val="FAFAFA"/>
+        </a:solidFill>
+      </p:bgPr>
+    </p:bg>
+    <p:spTree>
+      <p:nvGrpSpPr>
+        <p:cNvPr id="1" name=""/>
+        <p:cNvGrpSpPr/>
+        <p:nvPr/>
+      </p:nvGrpSpPr>
+      <p:grpSpPr>
+        <a:xfrm>
+          <a:off x="0" y="0"/>
+          <a:ext cx="0" cy="0"/>
+          <a:chOff x="0" y="0"/>
+          <a:chExt cx="0" cy="0"/>
+        </a:xfrm>
+      </p:grpSpPr>
+      <p:sp>
+        <p:nvSpPr>
+          <p:cNvPr id="2" name="Shape 0"/>
+          <p:cNvSpPr/>
+          <p:nvPr/>
+        </p:nvSpPr>
+        <p:spPr>
+          <a:xfrm>
+            <a:off x="0" y="0"/>
+            <a:ext cx="109728" cy="6858000"/>
+          </a:xfrm>
+          <a:prstGeom prst="rect">
+            <a:avLst/>
+          </a:prstGeom>
+          <a:solidFill>
+            <a:srgbClr val="4338CA"/>
+          </a:solidFill>
+          <a:ln w="12700">
+            <a:solidFill>
+              <a:srgbClr val="4338CA"/>
+            </a:solidFill>
+            <a:prstDash val="solid"/>
+          </a:ln>
+        </p:spPr>
+      </p:sp>
+      <p:sp>
+        <p:nvSpPr>
+          <p:cNvPr id="3" name="Text 1"/>
+          <p:cNvSpPr/>
+          <p:nvPr/>
+        </p:nvSpPr>
+        <p:spPr>
+          <a:xfrm>
+            <a:off x="411480" y="274320"/>
+            <a:ext cx="9144000" cy="182880"/>
+          </a:xfrm>
+          <a:prstGeom prst="rect">
+            <a:avLst/>
+          </a:prstGeom>
+          <a:noFill/>
+          <a:ln/>
+        </p:spPr>
+        <p:txBody>
+          <a:bodyPr wrap="square" lIns="0" tIns="0" rIns="0" bIns="0" rtlCol="0" anchor="ctr"/>
+          <a:lstStyle/>
+          <a:p>
+            <a:pPr indent="0" marL="0">
+              <a:buNone/>
+            </a:pPr>
+            <a:r>
+              <a:rPr lang="en-US" sz="800" b="1" spc="180" kern="0" dirty="0">
+                <a:solidFill>
+                  <a:srgbClr val="4338CA"/>
+                </a:solidFill>
+              </a:rPr>
+              <a:t>ROADMAP</a:t>
+            </a:r>
+            <a:endParaRPr lang="en-US" sz="800" dirty="0"/>
+          </a:p>
+        </p:txBody>
+      </p:sp>
+      <p:sp>
+        <p:nvSpPr>
+          <p:cNvPr id="4" name="Text 2"/>
+          <p:cNvSpPr/>
+          <p:nvPr/>
+        </p:nvSpPr>
+        <p:spPr>
+          <a:xfrm>
+            <a:off x="411480" y="530352"/>
+            <a:ext cx="10972800" cy="457200"/>
+          </a:xfrm>
+          <a:prstGeom prst="rect">
+            <a:avLst/>
+          </a:prstGeom>
+          <a:noFill/>
+          <a:ln/>
+        </p:spPr>
+        <p:txBody>
+          <a:bodyPr wrap="square" lIns="0" tIns="0" rIns="0" bIns="0" rtlCol="0" anchor="ctr"/>
+          <a:lstStyle/>
+          <a:p>
+            <a:pPr indent="0" marL="0">
+              <a:buNone/>
+            </a:pPr>
+            <a:r>
+              <a:rPr lang="en-US" sz="2800" b="1" dirty="0">
+                <a:solidFill>
+                  <a:srgbClr val="0A0A0A"/>
+                </a:solidFill>
+                <a:latin typeface="Aptos Display" pitchFamily="34" charset="0"/>
+                <a:ea typeface="Aptos Display" pitchFamily="34" charset="-122"/>
+                <a:cs typeface="Aptos Display" pitchFamily="34" charset="-120"/>
+              </a:rPr>
+              <a:t>After the pilot</a:t>
+            </a:r>
+            <a:endParaRPr lang="en-US" sz="2800" dirty="0"/>
+          </a:p>
+        </p:txBody>
+      </p:sp>
+      <p:sp>
+        <p:nvSpPr>
+          <p:cNvPr id="5" name="Shape 3"/>
+          <p:cNvSpPr/>
+          <p:nvPr/>
+        </p:nvSpPr>
+        <p:spPr>
+          <a:xfrm>
+            <a:off x="475488" y="1517904"/>
+            <a:ext cx="109728" cy="109728"/>
+          </a:xfrm>
+          <a:prstGeom prst="rect">
+            <a:avLst/>
+          </a:prstGeom>
+          <a:solidFill>
+            <a:srgbClr val="4338CA"/>
+          </a:solidFill>
+          <a:ln w="12700">
+            <a:solidFill>
+              <a:srgbClr val="4338CA"/>
+            </a:solidFill>
+            <a:prstDash val="solid"/>
+          </a:ln>
+        </p:spPr>
+      </p:sp>
+      <p:sp>
+        <p:nvSpPr>
+          <p:cNvPr id="6" name="Text 4"/>
+          <p:cNvSpPr/>
+          <p:nvPr/>
+        </p:nvSpPr>
+        <p:spPr>
+          <a:xfrm>
+            <a:off x="786384" y="1371600"/>
+            <a:ext cx="10515600" cy="548640"/>
+          </a:xfrm>
+          <a:prstGeom prst="rect">
+            <a:avLst/>
+          </a:prstGeom>
+          <a:noFill/>
+          <a:ln/>
+        </p:spPr>
+        <p:txBody>
+          <a:bodyPr wrap="square" lIns="0" tIns="0" rIns="0" bIns="0" rtlCol="0" anchor="ctr"/>
+          <a:lstStyle/>
+          <a:p>
+            <a:pPr indent="0" marL="0">
+              <a:buNone/>
+            </a:pPr>
+            <a:r>
+              <a:rPr lang="en-US" sz="2000" dirty="0">
+                <a:solidFill>
+                  <a:srgbClr val="0A0A0A"/>
+                </a:solidFill>
+              </a:rPr>
+              <a:t>Milestone planning and tracking</a:t>
+            </a:r>
+            <a:endParaRPr lang="en-US" sz="2000" dirty="0"/>
+          </a:p>
+        </p:txBody>
+      </p:sp>
+      <p:sp>
+        <p:nvSpPr>
+          <p:cNvPr id="7" name="Shape 5"/>
+          <p:cNvSpPr/>
+          <p:nvPr/>
+        </p:nvSpPr>
+        <p:spPr>
+          <a:xfrm>
+            <a:off x="475488" y="2450592"/>
+            <a:ext cx="109728" cy="109728"/>
+          </a:xfrm>
+          <a:prstGeom prst="rect">
+            <a:avLst/>
+          </a:prstGeom>
+          <a:solidFill>
+            <a:srgbClr val="4338CA"/>
+          </a:solidFill>
+          <a:ln w="12700">
+            <a:solidFill>
+              <a:srgbClr val="4338CA"/>
+            </a:solidFill>
+            <a:prstDash val="solid"/>
+          </a:ln>
+        </p:spPr>
+      </p:sp>
+      <p:sp>
+        <p:nvSpPr>
+          <p:cNvPr id="8" name="Text 6"/>
+          <p:cNvSpPr/>
+          <p:nvPr/>
+        </p:nvSpPr>
+        <p:spPr>
+          <a:xfrm>
+            <a:off x="786384" y="2304288"/>
+            <a:ext cx="10515600" cy="548640"/>
+          </a:xfrm>
+          <a:prstGeom prst="rect">
+            <a:avLst/>
+          </a:prstGeom>
+          <a:noFill/>
+          <a:ln/>
+        </p:spPr>
+        <p:txBody>
+          <a:bodyPr wrap="square" lIns="0" tIns="0" rIns="0" bIns="0" rtlCol="0" anchor="ctr"/>
+          <a:lstStyle/>
+          <a:p>
+            <a:pPr indent="0" marL="0">
+              <a:buNone/>
+            </a:pPr>
+            <a:r>
+              <a:rPr lang="en-US" sz="2000" dirty="0">
+                <a:solidFill>
+                  <a:srgbClr val="0A0A0A"/>
+                </a:solidFill>
+              </a:rPr>
+              <a:t>Minutes approval workflow</a:t>
+            </a:r>
+            <a:endParaRPr lang="en-US" sz="2000" dirty="0"/>
+          </a:p>
+        </p:txBody>
+      </p:sp>
+      <p:sp>
+        <p:nvSpPr>
+          <p:cNvPr id="9" name="Shape 7"/>
+          <p:cNvSpPr/>
+          <p:nvPr/>
+        </p:nvSpPr>
+        <p:spPr>
+          <a:xfrm>
+            <a:off x="475488" y="3383280"/>
+            <a:ext cx="109728" cy="109728"/>
+          </a:xfrm>
+          <a:prstGeom prst="rect">
+            <a:avLst/>
+          </a:prstGeom>
+          <a:solidFill>
+            <a:srgbClr val="4338CA"/>
+          </a:solidFill>
+          <a:ln w="12700">
+            <a:solidFill>
+              <a:srgbClr val="4338CA"/>
+            </a:solidFill>
+            <a:prstDash val="solid"/>
+          </a:ln>
+        </p:spPr>
+      </p:sp>
+      <p:sp>
+        <p:nvSpPr>
+          <p:cNvPr id="10" name="Text 8"/>
+          <p:cNvSpPr/>
+          <p:nvPr/>
+        </p:nvSpPr>
+        <p:spPr>
+          <a:xfrm>
+            <a:off x="786384" y="3236976"/>
+            <a:ext cx="10515600" cy="548640"/>
+          </a:xfrm>
+          <a:prstGeom prst="rect">
+            <a:avLst/>
+          </a:prstGeom>
+          <a:noFill/>
+          <a:ln/>
+        </p:spPr>
+        <p:txBody>
+          <a:bodyPr wrap="square" lIns="0" tIns="0" rIns="0" bIns="0" rtlCol="0" anchor="ctr"/>
+          <a:lstStyle/>
+          <a:p>
+            <a:pPr indent="0" marL="0">
+              <a:buNone/>
+            </a:pPr>
+            <a:r>
+              <a:rPr lang="en-US" sz="2000" dirty="0">
+                <a:solidFill>
+                  <a:srgbClr val="0A0A0A"/>
+                </a:solidFill>
+              </a:rPr>
+              <a:t>Technology readiness level (TRL) tracking</a:t>
+            </a:r>
+            <a:endParaRPr lang="en-US" sz="2000" dirty="0"/>
+          </a:p>
+        </p:txBody>
+      </p:sp>
+      <p:sp>
+        <p:nvSpPr>
+          <p:cNvPr id="11" name="Shape 9"/>
+          <p:cNvSpPr/>
+          <p:nvPr/>
+        </p:nvSpPr>
+        <p:spPr>
+          <a:xfrm>
+            <a:off x="475488" y="4315968"/>
+            <a:ext cx="109728" cy="109728"/>
+          </a:xfrm>
+          <a:prstGeom prst="rect">
+            <a:avLst/>
+          </a:prstGeom>
+          <a:solidFill>
+            <a:srgbClr val="4338CA"/>
+          </a:solidFill>
+          <a:ln w="12700">
+            <a:solidFill>
+              <a:srgbClr val="4338CA"/>
+            </a:solidFill>
+            <a:prstDash val="solid"/>
+          </a:ln>
+        </p:spPr>
+      </p:sp>
+      <p:sp>
+        <p:nvSpPr>
+          <p:cNvPr id="12" name="Text 10"/>
+          <p:cNvSpPr/>
+          <p:nvPr/>
+        </p:nvSpPr>
+        <p:spPr>
+          <a:xfrm>
+            <a:off x="786384" y="4169664"/>
+            <a:ext cx="10515600" cy="548640"/>
+          </a:xfrm>
+          <a:prstGeom prst="rect">
+            <a:avLst/>
+          </a:prstGeom>
+          <a:noFill/>
+          <a:ln/>
+        </p:spPr>
+        <p:txBody>
+          <a:bodyPr wrap="square" lIns="0" tIns="0" rIns="0" bIns="0" rtlCol="0" anchor="ctr"/>
+          <a:lstStyle/>
+          <a:p>
+            <a:pPr indent="0" marL="0">
+              <a:buNone/>
+            </a:pPr>
+            <a:r>
+              <a:rPr lang="en-US" sz="2000" dirty="0">
+                <a:solidFill>
+                  <a:srgbClr val="0A0A0A"/>
+                </a:solidFill>
+              </a:rPr>
+              <a:t>Multi-level review</a:t>
+            </a:r>
+            <a:endParaRPr lang="en-US" sz="2000" dirty="0"/>
+          </a:p>
+        </p:txBody>
+      </p:sp>
+      <p:sp>
+        <p:nvSpPr>
+          <p:cNvPr id="13" name="Shape 11"/>
+          <p:cNvSpPr/>
+          <p:nvPr/>
+        </p:nvSpPr>
+        <p:spPr>
+          <a:xfrm>
+            <a:off x="475488" y="5248656"/>
+            <a:ext cx="109728" cy="109728"/>
+          </a:xfrm>
+          <a:prstGeom prst="rect">
+            <a:avLst/>
+          </a:prstGeom>
+          <a:solidFill>
+            <a:srgbClr val="4338CA"/>
+          </a:solidFill>
+          <a:ln w="12700">
+            <a:solidFill>
+              <a:srgbClr val="4338CA"/>
+            </a:solidFill>
+            <a:prstDash val="solid"/>
+          </a:ln>
+        </p:spPr>
+      </p:sp>
+      <p:sp>
+        <p:nvSpPr>
+          <p:cNvPr id="14" name="Text 12"/>
+          <p:cNvSpPr/>
+          <p:nvPr/>
+        </p:nvSpPr>
+        <p:spPr>
+          <a:xfrm>
+            <a:off x="786384" y="5102352"/>
+            <a:ext cx="10515600" cy="548640"/>
+          </a:xfrm>
+          <a:prstGeom prst="rect">
+            <a:avLst/>
+          </a:prstGeom>
+          <a:noFill/>
+          <a:ln/>
+        </p:spPr>
+        <p:txBody>
+          <a:bodyPr wrap="square" lIns="0" tIns="0" rIns="0" bIns="0" rtlCol="0" anchor="ctr"/>
+          <a:lstStyle/>
+          <a:p>
+            <a:pPr indent="0" marL="0">
+              <a:buNone/>
+            </a:pPr>
+            <a:r>
+              <a:rPr lang="en-US" sz="2000" dirty="0">
+                <a:solidFill>
+                  <a:srgbClr val="0A0A0A"/>
+                </a:solidFill>
+              </a:rPr>
+              <a:t>On-premise deployment and object storage</a:t>
+            </a:r>
+            <a:endParaRPr lang="en-US" sz="2000" dirty="0"/>
+          </a:p>
+        </p:txBody>
+      </p:sp>
+      <p:sp>
+        <p:nvSpPr>
+          <p:cNvPr id="15" name="Text 13"/>
+          <p:cNvSpPr/>
+          <p:nvPr/>
+        </p:nvSpPr>
+        <p:spPr>
+          <a:xfrm>
+            <a:off x="411480" y="6519672"/>
+            <a:ext cx="6400800" cy="182880"/>
+          </a:xfrm>
+          <a:prstGeom prst="rect">
+            <a:avLst/>
+          </a:prstGeom>
+          <a:noFill/>
+          <a:ln/>
+        </p:spPr>
+        <p:txBody>
+          <a:bodyPr wrap="square" lIns="0" tIns="0" rIns="0" bIns="0" rtlCol="0" anchor="ctr"/>
+          <a:lstStyle/>
+          <a:p>
+            <a:pPr indent="0" marL="0">
+              <a:buNone/>
+            </a:pPr>
+            <a:r>
+              <a:rPr lang="en-US" sz="800" b="1" spc="100" kern="0" dirty="0">
+                <a:solidFill>
+                  <a:srgbClr val="52525B"/>
+                </a:solidFill>
+              </a:rPr>
+              <a:t>PLANNED  /  NOT IN CURRENT DEMO</a:t>
+            </a:r>
+            <a:endParaRPr lang="en-US" sz="800" dirty="0"/>
+          </a:p>
+        </p:txBody>
+      </p:sp>
+      <p:sp>
+        <p:nvSpPr>
+          <p:cNvPr id="16" name="Text 14"/>
+          <p:cNvSpPr/>
+          <p:nvPr/>
+        </p:nvSpPr>
+        <p:spPr>
+          <a:xfrm>
+            <a:off x="11018520" y="6510528"/>
+            <a:ext cx="685800" cy="228600"/>
+          </a:xfrm>
+          <a:prstGeom prst="rect">
+            <a:avLst/>
+          </a:prstGeom>
+          <a:noFill/>
+          <a:ln/>
+        </p:spPr>
+        <p:txBody>
+          <a:bodyPr wrap="square" lIns="0" tIns="0" rIns="0" bIns="0" rtlCol="0" anchor="ctr"/>
+          <a:lstStyle/>
+          <a:p>
+            <a:pPr algn="r" indent="0" marL="0">
+              <a:buNone/>
+            </a:pPr>
+            <a:r>
+              <a:rPr lang="en-US" sz="900" dirty="0">
+                <a:solidFill>
+                  <a:srgbClr val="52525B"/>
+                </a:solidFill>
+              </a:rPr>
+              <a:t>09 / 09</a:t>
             </a:r>
             <a:endParaRPr lang="en-US" sz="900" dirty="0"/>
           </a:p>

</xml_diff>